<commit_message>
Add "How the risk score is calculated" slide to the demo deck
Walks through the scoring formula (tier weights, banned/allergen
bonuses, score cap, label bands) with two worked examples verified
against the live database.
</commit_message>
<xml_diff>
--- a/docs/IngredientIQ-Demo.pptx
+++ b/docs/IngredientIQ-Demo.pptx
@@ -16,9 +16,10 @@
     <p:sldId id="264" r:id="rId10"/>
     <p:sldId id="265" r:id="rId11"/>
     <p:sldId id="266" r:id="rId12"/>
+    <p:sldId id="267" r:id="rId13"/>
   </p:sldIdLst>
   <p:notesMasterIdLst>
-    <p:notesMasterId r:id="rId13"/>
+    <p:notesMasterId r:id="rId14"/>
   </p:notesMasterIdLst>
   <p:sldSz cx="12192000" cy="6858000"/>
   <p:notesSz cx="6858000" cy="12192000"/>
@@ -730,6 +731,94 @@
 </p:notes>
 </file>
 
+<file path=ppt/notesSlides/notesSlide12.xml><?xml version="1.0" encoding="utf-8"?>
+<p:notes xmlns:a="http://schemas.openxmlformats.org/drawingml/2006/main" xmlns:r="http://schemas.openxmlformats.org/officeDocument/2006/relationships" xmlns:p="http://schemas.openxmlformats.org/presentationml/2006/main">
+  <p:cSld>
+    <p:spTree>
+      <p:nvGrpSpPr>
+        <p:cNvPr id="1" name=""/>
+        <p:cNvGrpSpPr/>
+        <p:nvPr/>
+      </p:nvGrpSpPr>
+      <p:grpSpPr>
+        <a:xfrm>
+          <a:off x="0" y="0"/>
+          <a:ext cx="0" cy="0"/>
+          <a:chOff x="0" y="0"/>
+          <a:chExt cx="0" cy="0"/>
+        </a:xfrm>
+      </p:grpSpPr>
+      <p:sp>
+        <p:nvSpPr>
+          <p:cNvPr id="2" name="Slide Image Placeholder 1"/>
+          <p:cNvSpPr>
+            <a:spLocks noGrp="1" noRot="1" noChangeAspect="1"/>
+          </p:cNvSpPr>
+          <p:nvPr>
+            <p:ph type="sldImg"/>
+          </p:nvPr>
+        </p:nvSpPr>
+        <p:spPr/>
+      </p:sp>
+      <p:sp>
+        <p:nvSpPr>
+          <p:cNvPr id="3" name="Notes Placeholder 2"/>
+          <p:cNvSpPr>
+            <a:spLocks noGrp="1"/>
+          </p:cNvSpPr>
+          <p:nvPr>
+            <p:ph type="body" idx="1"/>
+          </p:nvPr>
+        </p:nvSpPr>
+        <p:spPr/>
+        <p:txBody>
+          <a:bodyPr/>
+          <a:lstStyle/>
+          <a:p>
+            <a:r>
+              <a:rPr lang="en-US" dirty="0"/>
+              <a:t/>
+            </a:r>
+            <a:endParaRPr lang="en-US" dirty="0"/>
+          </a:p>
+        </p:txBody>
+      </p:sp>
+      <p:sp>
+        <p:nvSpPr>
+          <p:cNvPr id="4" name="Slide Number Placeholder 3"/>
+          <p:cNvSpPr>
+            <a:spLocks noGrp="1"/>
+          </p:cNvSpPr>
+          <p:nvPr>
+            <p:ph type="sldNum" sz="quarter" idx="10"/>
+          </p:nvPr>
+        </p:nvSpPr>
+        <p:spPr/>
+        <p:txBody>
+          <a:bodyPr/>
+          <a:lstStyle/>
+          <a:p>
+            <a:fld id="{F7021451-1387-4CA6-816F-3879F97B5CBC}" type="slidenum">
+              <a:rPr lang="en-US"/>
+              <a:t>12</a:t>
+            </a:fld>
+            <a:endParaRPr lang="en-US"/>
+          </a:p>
+        </p:txBody>
+      </p:sp>
+    </p:spTree>
+    <p:extLst>
+      <p:ext uri="{BB962C8B-B14F-4D97-AF65-F5344CB8AC3E}">
+        <p14:creationId xmlns:p14="http://schemas.microsoft.com/office/powerpoint/2010/main" val="1024086991"/>
+      </p:ext>
+    </p:extLst>
+  </p:cSld>
+  <p:clrMapOvr>
+    <a:masterClrMapping/>
+  </p:clrMapOvr>
+</p:notes>
+</file>
+
 <file path=ppt/notesSlides/notesSlide2.xml><?xml version="1.0" encoding="utf-8"?>
 <p:notes xmlns:a="http://schemas.openxmlformats.org/drawingml/2006/main" xmlns:r="http://schemas.openxmlformats.org/officeDocument/2006/relationships" xmlns:p="http://schemas.openxmlformats.org/presentationml/2006/main">
   <p:cSld>
@@ -1991,7 +2080,7 @@
                 <a:ea typeface="Calibri" pitchFamily="34" charset="-122"/>
                 <a:cs typeface="Calibri" pitchFamily="34" charset="-120"/>
               </a:rPr>
-              <a:t>ALTERNATIVES EXPLORED</a:t>
+              <a:t>ROADBLOCKS</a:t>
             </a:r>
             <a:endParaRPr lang="en-US" sz="1200" dirty="0"/>
           </a:p>
@@ -2022,7 +2111,7 @@
               <a:buNone/>
             </a:pPr>
             <a:r>
-              <a:rPr lang="en-US" sz="2500" b="1" dirty="0">
+              <a:rPr lang="en-US" sz="3000" b="1" dirty="0">
                 <a:solidFill>
                   <a:srgbClr val="0B2F42"/>
                 </a:solidFill>
@@ -2030,6 +2119,521 @@
                 <a:ea typeface="Cambria" pitchFamily="34" charset="-122"/>
                 <a:cs typeface="Cambria" pitchFamily="34" charset="-120"/>
               </a:rPr>
+              <a:t>Real friction, worked through</a:t>
+            </a:r>
+            <a:endParaRPr lang="en-US" sz="3000" dirty="0"/>
+          </a:p>
+        </p:txBody>
+      </p:sp>
+      <p:sp>
+        <p:nvSpPr>
+          <p:cNvPr id="4" name="Shape 2"/>
+          <p:cNvSpPr/>
+          <p:nvPr/>
+        </p:nvSpPr>
+        <p:spPr>
+          <a:xfrm>
+            <a:off x="731520" y="2331720"/>
+            <a:ext cx="566928" cy="566928"/>
+          </a:xfrm>
+          <a:prstGeom prst="ellipse">
+            <a:avLst/>
+          </a:prstGeom>
+          <a:solidFill>
+            <a:srgbClr val="E24B4A"/>
+          </a:solidFill>
+          <a:ln/>
+        </p:spPr>
+      </p:sp>
+      <p:pic>
+        <p:nvPicPr>
+          <p:cNvPr id="5" name="Image 0" descr="icon-bug.png">    </p:cNvPr>
+          <p:cNvPicPr>
+            <a:picLocks noChangeAspect="1"/>
+          </p:cNvPicPr>
+          <p:nvPr/>
+        </p:nvPicPr>
+        <p:blipFill>
+          <a:blip r:embed="rId1"/>
+          <a:stretch>
+            <a:fillRect/>
+          </a:stretch>
+        </p:blipFill>
+        <p:spPr>
+          <a:xfrm>
+            <a:off x="810890" y="2411090"/>
+            <a:ext cx="408188" cy="408188"/>
+          </a:xfrm>
+          <a:prstGeom prst="rect">
+            <a:avLst/>
+          </a:prstGeom>
+        </p:spPr>
+      </p:pic>
+      <p:sp>
+        <p:nvSpPr>
+          <p:cNvPr id="6" name="Text 3"/>
+          <p:cNvSpPr/>
+          <p:nvPr/>
+        </p:nvSpPr>
+        <p:spPr>
+          <a:xfrm>
+            <a:off x="1527048" y="2295144"/>
+            <a:ext cx="9811512" cy="320040"/>
+          </a:xfrm>
+          <a:prstGeom prst="rect">
+            <a:avLst/>
+          </a:prstGeom>
+          <a:noFill/>
+          <a:ln/>
+        </p:spPr>
+        <p:txBody>
+          <a:bodyPr wrap="square" lIns="0" tIns="0" rIns="0" bIns="0" rtlCol="0" anchor="ctr"/>
+          <a:lstStyle/>
+          <a:p>
+            <a:pPr indent="0" marL="0">
+              <a:buNone/>
+            </a:pPr>
+            <a:r>
+              <a:rPr lang="en-US" sz="1600" b="1" dirty="0">
+                <a:solidFill>
+                  <a:srgbClr val="1F2933"/>
+                </a:solidFill>
+                <a:latin typeface="Calibri" pitchFamily="34" charset="0"/>
+                <a:ea typeface="Calibri" pitchFamily="34" charset="-122"/>
+                <a:cs typeface="Calibri" pitchFamily="34" charset="-120"/>
+              </a:rPr>
+              <a:t>Silent zero-database bug</a:t>
+            </a:r>
+            <a:endParaRPr lang="en-US" sz="1600" dirty="0"/>
+          </a:p>
+        </p:txBody>
+      </p:sp>
+      <p:sp>
+        <p:nvSpPr>
+          <p:cNvPr id="7" name="Text 4"/>
+          <p:cNvSpPr/>
+          <p:nvPr/>
+        </p:nvSpPr>
+        <p:spPr>
+          <a:xfrm>
+            <a:off x="1527048" y="2624328"/>
+            <a:ext cx="9811512" cy="685800"/>
+          </a:xfrm>
+          <a:prstGeom prst="rect">
+            <a:avLst/>
+          </a:prstGeom>
+          <a:noFill/>
+          <a:ln/>
+        </p:spPr>
+        <p:txBody>
+          <a:bodyPr wrap="square" lIns="0" tIns="0" rIns="0" bIns="0" rtlCol="0" anchor="t"/>
+          <a:lstStyle/>
+          <a:p>
+            <a:pPr indent="0" marL="0">
+              <a:buNone/>
+            </a:pPr>
+            <a:r>
+              <a:rPr lang="en-US" sz="1250" dirty="0">
+                <a:solidFill>
+                  <a:srgbClr val="5B6B79"/>
+                </a:solidFill>
+                <a:latin typeface="Calibri" pitchFamily="34" charset="0"/>
+                <a:ea typeface="Calibri" pitchFamily="34" charset="-122"/>
+                <a:cs typeface="Calibri" pitchFamily="34" charset="-120"/>
+              </a:rPr>
+              <a:t>The bundled ingredients.json had a schema mismatch — the app was quietly running with zero ingredients loaded and no error shown. Root-caused by compiling the matching logic standalone and testing it directly against the actual bundled file.</a:t>
+            </a:r>
+            <a:endParaRPr lang="en-US" sz="1250" dirty="0"/>
+          </a:p>
+        </p:txBody>
+      </p:sp>
+      <p:sp>
+        <p:nvSpPr>
+          <p:cNvPr id="8" name="Shape 5"/>
+          <p:cNvSpPr/>
+          <p:nvPr/>
+        </p:nvSpPr>
+        <p:spPr>
+          <a:xfrm>
+            <a:off x="731520" y="3703320"/>
+            <a:ext cx="566928" cy="566928"/>
+          </a:xfrm>
+          <a:prstGeom prst="ellipse">
+            <a:avLst/>
+          </a:prstGeom>
+          <a:solidFill>
+            <a:srgbClr val="1C7293"/>
+          </a:solidFill>
+          <a:ln/>
+        </p:spPr>
+      </p:sp>
+      <p:pic>
+        <p:nvPicPr>
+          <p:cNvPr id="9" name="Image 1" descr="icon-route.png">    </p:cNvPr>
+          <p:cNvPicPr>
+            <a:picLocks noChangeAspect="1"/>
+          </p:cNvPicPr>
+          <p:nvPr/>
+        </p:nvPicPr>
+        <p:blipFill>
+          <a:blip r:embed="rId2"/>
+          <a:stretch>
+            <a:fillRect/>
+          </a:stretch>
+        </p:blipFill>
+        <p:spPr>
+          <a:xfrm>
+            <a:off x="810890" y="3782690"/>
+            <a:ext cx="408188" cy="408188"/>
+          </a:xfrm>
+          <a:prstGeom prst="rect">
+            <a:avLst/>
+          </a:prstGeom>
+        </p:spPr>
+      </p:pic>
+      <p:sp>
+        <p:nvSpPr>
+          <p:cNvPr id="10" name="Text 6"/>
+          <p:cNvSpPr/>
+          <p:nvPr/>
+        </p:nvSpPr>
+        <p:spPr>
+          <a:xfrm>
+            <a:off x="1527048" y="3666744"/>
+            <a:ext cx="9811512" cy="320040"/>
+          </a:xfrm>
+          <a:prstGeom prst="rect">
+            <a:avLst/>
+          </a:prstGeom>
+          <a:noFill/>
+          <a:ln/>
+        </p:spPr>
+        <p:txBody>
+          <a:bodyPr wrap="square" lIns="0" tIns="0" rIns="0" bIns="0" rtlCol="0" anchor="ctr"/>
+          <a:lstStyle/>
+          <a:p>
+            <a:pPr indent="0" marL="0">
+              <a:buNone/>
+            </a:pPr>
+            <a:r>
+              <a:rPr lang="en-US" sz="1600" b="1" dirty="0">
+                <a:solidFill>
+                  <a:srgbClr val="1F2933"/>
+                </a:solidFill>
+                <a:latin typeface="Calibri" pitchFamily="34" charset="0"/>
+                <a:ea typeface="Calibri" pitchFamily="34" charset="-122"/>
+                <a:cs typeface="Calibri" pitchFamily="34" charset="-120"/>
+              </a:rPr>
+              <a:t>Multi-target iOS setup</a:t>
+            </a:r>
+            <a:endParaRPr lang="en-US" sz="1600" dirty="0"/>
+          </a:p>
+        </p:txBody>
+      </p:sp>
+      <p:sp>
+        <p:nvSpPr>
+          <p:cNvPr id="11" name="Text 7"/>
+          <p:cNvSpPr/>
+          <p:nvPr/>
+        </p:nvSpPr>
+        <p:spPr>
+          <a:xfrm>
+            <a:off x="1527048" y="3995928"/>
+            <a:ext cx="9811512" cy="685800"/>
+          </a:xfrm>
+          <a:prstGeom prst="rect">
+            <a:avLst/>
+          </a:prstGeom>
+          <a:noFill/>
+          <a:ln/>
+        </p:spPr>
+        <p:txBody>
+          <a:bodyPr wrap="square" lIns="0" tIns="0" rIns="0" bIns="0" rtlCol="0" anchor="t"/>
+          <a:lstStyle/>
+          <a:p>
+            <a:pPr indent="0" marL="0">
+              <a:buNone/>
+            </a:pPr>
+            <a:r>
+              <a:rPr lang="en-US" sz="1250" dirty="0">
+                <a:solidFill>
+                  <a:srgbClr val="5B6B79"/>
+                </a:solidFill>
+                <a:latin typeface="Calibri" pitchFamily="34" charset="0"/>
+                <a:ea typeface="Calibri" pitchFamily="34" charset="-122"/>
+                <a:cs typeface="Calibri" pitchFamily="34" charset="-120"/>
+              </a:rPr>
+              <a:t>App Groups, per-target file membership, and Info.plist entitlements all had to be wired by hand across two build targets (container app + keyboard extension) in Xcode.</a:t>
+            </a:r>
+            <a:endParaRPr lang="en-US" sz="1250" dirty="0"/>
+          </a:p>
+        </p:txBody>
+      </p:sp>
+      <p:sp>
+        <p:nvSpPr>
+          <p:cNvPr id="12" name="Shape 8"/>
+          <p:cNvSpPr/>
+          <p:nvPr/>
+        </p:nvSpPr>
+        <p:spPr>
+          <a:xfrm>
+            <a:off x="731520" y="5074920"/>
+            <a:ext cx="566928" cy="566928"/>
+          </a:xfrm>
+          <a:prstGeom prst="ellipse">
+            <a:avLst/>
+          </a:prstGeom>
+          <a:solidFill>
+            <a:srgbClr val="0B2F42"/>
+          </a:solidFill>
+          <a:ln/>
+        </p:spPr>
+      </p:sp>
+      <p:pic>
+        <p:nvPicPr>
+          <p:cNvPr id="13" name="Image 2" descr="icon-mobile.png">    </p:cNvPr>
+          <p:cNvPicPr>
+            <a:picLocks noChangeAspect="1"/>
+          </p:cNvPicPr>
+          <p:nvPr/>
+        </p:nvPicPr>
+        <p:blipFill>
+          <a:blip r:embed="rId3"/>
+          <a:stretch>
+            <a:fillRect/>
+          </a:stretch>
+        </p:blipFill>
+        <p:spPr>
+          <a:xfrm>
+            <a:off x="810890" y="5154290"/>
+            <a:ext cx="408188" cy="408188"/>
+          </a:xfrm>
+          <a:prstGeom prst="rect">
+            <a:avLst/>
+          </a:prstGeom>
+        </p:spPr>
+      </p:pic>
+      <p:sp>
+        <p:nvSpPr>
+          <p:cNvPr id="14" name="Text 9"/>
+          <p:cNvSpPr/>
+          <p:nvPr/>
+        </p:nvSpPr>
+        <p:spPr>
+          <a:xfrm>
+            <a:off x="1527048" y="5038344"/>
+            <a:ext cx="9811512" cy="320040"/>
+          </a:xfrm>
+          <a:prstGeom prst="rect">
+            <a:avLst/>
+          </a:prstGeom>
+          <a:noFill/>
+          <a:ln/>
+        </p:spPr>
+        <p:txBody>
+          <a:bodyPr wrap="square" lIns="0" tIns="0" rIns="0" bIns="0" rtlCol="0" anchor="ctr"/>
+          <a:lstStyle/>
+          <a:p>
+            <a:pPr indent="0" marL="0">
+              <a:buNone/>
+            </a:pPr>
+            <a:r>
+              <a:rPr lang="en-US" sz="1600" b="1" dirty="0">
+                <a:solidFill>
+                  <a:srgbClr val="1F2933"/>
+                </a:solidFill>
+                <a:latin typeface="Calibri" pitchFamily="34" charset="0"/>
+                <a:ea typeface="Calibri" pitchFamily="34" charset="-122"/>
+                <a:cs typeface="Calibri" pitchFamily="34" charset="-120"/>
+              </a:rPr>
+              <a:t>Real-device provisioning</a:t>
+            </a:r>
+            <a:endParaRPr lang="en-US" sz="1600" dirty="0"/>
+          </a:p>
+        </p:txBody>
+      </p:sp>
+      <p:sp>
+        <p:nvSpPr>
+          <p:cNvPr id="15" name="Text 10"/>
+          <p:cNvSpPr/>
+          <p:nvPr/>
+        </p:nvSpPr>
+        <p:spPr>
+          <a:xfrm>
+            <a:off x="1527048" y="5367528"/>
+            <a:ext cx="9811512" cy="685800"/>
+          </a:xfrm>
+          <a:prstGeom prst="rect">
+            <a:avLst/>
+          </a:prstGeom>
+          <a:noFill/>
+          <a:ln/>
+        </p:spPr>
+        <p:txBody>
+          <a:bodyPr wrap="square" lIns="0" tIns="0" rIns="0" bIns="0" rtlCol="0" anchor="t"/>
+          <a:lstStyle/>
+          <a:p>
+            <a:pPr indent="0" marL="0">
+              <a:buNone/>
+            </a:pPr>
+            <a:r>
+              <a:rPr lang="en-US" sz="1250" dirty="0">
+                <a:solidFill>
+                  <a:srgbClr val="5B6B79"/>
+                </a:solidFill>
+                <a:latin typeface="Calibri" pitchFamily="34" charset="0"/>
+                <a:ea typeface="Calibri" pitchFamily="34" charset="-122"/>
+                <a:cs typeface="Calibri" pitchFamily="34" charset="-120"/>
+              </a:rPr>
+              <a:t>Scheme vs. destination mixups, trust dialogs, and first-run code-signing friction before the extension could run on a physical iPhone.</a:t>
+            </a:r>
+            <a:endParaRPr lang="en-US" sz="1250" dirty="0"/>
+          </a:p>
+        </p:txBody>
+      </p:sp>
+      <p:sp>
+        <p:nvSpPr>
+          <p:cNvPr id="16" name="Text 11"/>
+          <p:cNvSpPr/>
+          <p:nvPr/>
+        </p:nvSpPr>
+        <p:spPr>
+          <a:xfrm>
+            <a:off x="11521440" y="6400800"/>
+            <a:ext cx="365760" cy="274320"/>
+          </a:xfrm>
+          <a:prstGeom prst="rect">
+            <a:avLst/>
+          </a:prstGeom>
+          <a:noFill/>
+          <a:ln/>
+        </p:spPr>
+        <p:txBody>
+          <a:bodyPr wrap="square" lIns="0" tIns="0" rIns="0" bIns="0" rtlCol="0" anchor="ctr"/>
+          <a:lstStyle/>
+          <a:p>
+            <a:pPr algn="r" indent="0" marL="0">
+              <a:buNone/>
+            </a:pPr>
+            <a:r>
+              <a:rPr lang="en-US" sz="1000" dirty="0">
+                <a:solidFill>
+                  <a:srgbClr val="5B6B79"/>
+                </a:solidFill>
+                <a:latin typeface="Calibri" pitchFamily="34" charset="0"/>
+                <a:ea typeface="Calibri" pitchFamily="34" charset="-122"/>
+                <a:cs typeface="Calibri" pitchFamily="34" charset="-120"/>
+              </a:rPr>
+              <a:t>10</a:t>
+            </a:r>
+            <a:endParaRPr lang="en-US" sz="1000" dirty="0"/>
+          </a:p>
+        </p:txBody>
+      </p:sp>
+    </p:spTree>
+  </p:cSld>
+  <p:clrMapOvr>
+    <a:masterClrMapping/>
+  </p:clrMapOvr>
+</p:sld>
+</file>
+
+<file path=ppt/slides/slide11.xml><?xml version="1.0" encoding="utf-8"?>
+<p:sld xmlns:a="http://schemas.openxmlformats.org/drawingml/2006/main" xmlns:r="http://schemas.openxmlformats.org/officeDocument/2006/relationships" xmlns:p="http://schemas.openxmlformats.org/presentationml/2006/main">
+  <p:cSld name="Slide 11">
+    <p:bg>
+      <p:bgPr>
+        <a:solidFill>
+          <a:srgbClr val="FFFFFF"/>
+        </a:solidFill>
+      </p:bgPr>
+    </p:bg>
+    <p:spTree>
+      <p:nvGrpSpPr>
+        <p:cNvPr id="1" name=""/>
+        <p:cNvGrpSpPr/>
+        <p:nvPr/>
+      </p:nvGrpSpPr>
+      <p:grpSpPr>
+        <a:xfrm>
+          <a:off x="0" y="0"/>
+          <a:ext cx="0" cy="0"/>
+          <a:chOff x="0" y="0"/>
+          <a:chExt cx="0" cy="0"/>
+        </a:xfrm>
+      </p:grpSpPr>
+      <p:sp>
+        <p:nvSpPr>
+          <p:cNvPr id="2" name="Text 0"/>
+          <p:cNvSpPr/>
+          <p:nvPr/>
+        </p:nvSpPr>
+        <p:spPr>
+          <a:xfrm>
+            <a:off x="731520" y="502920"/>
+            <a:ext cx="5486400" cy="320040"/>
+          </a:xfrm>
+          <a:prstGeom prst="rect">
+            <a:avLst/>
+          </a:prstGeom>
+          <a:noFill/>
+          <a:ln/>
+        </p:spPr>
+        <p:txBody>
+          <a:bodyPr wrap="square" lIns="0" tIns="0" rIns="0" bIns="0" rtlCol="0" anchor="ctr"/>
+          <a:lstStyle/>
+          <a:p>
+            <a:pPr indent="0" marL="0">
+              <a:buNone/>
+            </a:pPr>
+            <a:r>
+              <a:rPr lang="en-US" sz="1200" b="1" spc="200" kern="0" dirty="0">
+                <a:solidFill>
+                  <a:srgbClr val="F2994A"/>
+                </a:solidFill>
+                <a:latin typeface="Calibri" pitchFamily="34" charset="0"/>
+                <a:ea typeface="Calibri" pitchFamily="34" charset="-122"/>
+                <a:cs typeface="Calibri" pitchFamily="34" charset="-120"/>
+              </a:rPr>
+              <a:t>ALTERNATIVES EXPLORED</a:t>
+            </a:r>
+            <a:endParaRPr lang="en-US" sz="1200" dirty="0"/>
+          </a:p>
+        </p:txBody>
+      </p:sp>
+      <p:sp>
+        <p:nvSpPr>
+          <p:cNvPr id="3" name="Text 1"/>
+          <p:cNvSpPr/>
+          <p:nvPr/>
+        </p:nvSpPr>
+        <p:spPr>
+          <a:xfrm>
+            <a:off x="731520" y="868680"/>
+            <a:ext cx="10607040" cy="731520"/>
+          </a:xfrm>
+          <a:prstGeom prst="rect">
+            <a:avLst/>
+          </a:prstGeom>
+          <a:noFill/>
+          <a:ln/>
+        </p:spPr>
+        <p:txBody>
+          <a:bodyPr wrap="square" lIns="0" tIns="0" rIns="0" bIns="0" rtlCol="0" anchor="ctr"/>
+          <a:lstStyle/>
+          <a:p>
+            <a:pPr indent="0" marL="0">
+              <a:buNone/>
+            </a:pPr>
+            <a:r>
+              <a:rPr lang="en-US" sz="2500" b="1" dirty="0">
+                <a:solidFill>
+                  <a:srgbClr val="0B2F42"/>
+                </a:solidFill>
+                <a:latin typeface="Cambria" pitchFamily="34" charset="0"/>
+                <a:ea typeface="Cambria" pitchFamily="34" charset="-122"/>
+                <a:cs typeface="Cambria" pitchFamily="34" charset="-120"/>
+              </a:rPr>
               <a:t>What we tried before landing on the keyboard extension</a:t>
             </a:r>
             <a:endParaRPr lang="en-US" sz="2500" dirty="0"/>
@@ -2038,7 +2642,7 @@
       </p:sp>
       <p:graphicFrame>
         <p:nvGraphicFramePr>
-          <p:cNvPr id="11" name="Table 0"/>
+          <p:cNvPr id="12" name="Table 0"/>
           <p:cNvGraphicFramePr>
             <a:graphicFrameLocks noGrp="1"/>
           </p:cNvGraphicFramePr>
@@ -2719,7 +3323,7 @@
                 <a:ea typeface="Calibri" pitchFamily="34" charset="-122"/>
                 <a:cs typeface="Calibri" pitchFamily="34" charset="-120"/>
               </a:rPr>
-              <a:t>10</a:t>
+              <a:t>11</a:t>
             </a:r>
             <a:endParaRPr lang="en-US" sz="1000" dirty="0"/>
           </a:p>
@@ -2733,9 +3337,9 @@
 </p:sld>
 </file>
 
-<file path=ppt/slides/slide11.xml><?xml version="1.0" encoding="utf-8"?>
+<file path=ppt/slides/slide12.xml><?xml version="1.0" encoding="utf-8"?>
 <p:sld xmlns:a="http://schemas.openxmlformats.org/drawingml/2006/main" xmlns:r="http://schemas.openxmlformats.org/officeDocument/2006/relationships" xmlns:p="http://schemas.openxmlformats.org/presentationml/2006/main">
-  <p:cSld name="Slide 11">
+  <p:cSld name="Slide 12">
     <p:bg>
       <p:bgPr>
         <a:solidFill>
@@ -10345,7 +10949,7 @@
                 <a:ea typeface="Calibri" pitchFamily="34" charset="-122"/>
                 <a:cs typeface="Calibri" pitchFamily="34" charset="-120"/>
               </a:rPr>
-              <a:t>ROADBLOCKS</a:t>
+              <a:t>HOW IT WORKS</a:t>
             </a:r>
             <a:endParaRPr lang="en-US" sz="1200" dirty="0"/>
           </a:p>
@@ -10384,7 +10988,7 @@
                 <a:ea typeface="Cambria" pitchFamily="34" charset="-122"/>
                 <a:cs typeface="Cambria" pitchFamily="34" charset="-120"/>
               </a:rPr>
-              <a:t>Real friction, worked through</a:t>
+              <a:t>How the risk score is calculated</a:t>
             </a:r>
             <a:endParaRPr lang="en-US" sz="3000" dirty="0"/>
           </a:p>
@@ -10398,68 +11002,164 @@
         </p:nvSpPr>
         <p:spPr>
           <a:xfrm>
-            <a:off x="731520" y="2331720"/>
-            <a:ext cx="566928" cy="566928"/>
+            <a:off x="731520" y="1828800"/>
+            <a:ext cx="3337560" cy="2560320"/>
+          </a:xfrm>
+          <a:prstGeom prst="roundRect">
+            <a:avLst>
+              <a:gd name="adj" fmla="val 2857"/>
+            </a:avLst>
+          </a:prstGeom>
+          <a:solidFill>
+            <a:srgbClr val="EAF3F6"/>
+          </a:solidFill>
+          <a:ln/>
+        </p:spPr>
+      </p:sp>
+      <p:sp>
+        <p:nvSpPr>
+          <p:cNvPr id="5" name="Shape 3"/>
+          <p:cNvSpPr/>
+          <p:nvPr/>
+        </p:nvSpPr>
+        <p:spPr>
+          <a:xfrm>
+            <a:off x="1005840" y="2103120"/>
+            <a:ext cx="365760" cy="365760"/>
           </a:xfrm>
           <a:prstGeom prst="ellipse">
             <a:avLst/>
           </a:prstGeom>
           <a:solidFill>
+            <a:srgbClr val="0B2F42"/>
+          </a:solidFill>
+          <a:ln/>
+        </p:spPr>
+      </p:sp>
+      <p:sp>
+        <p:nvSpPr>
+          <p:cNvPr id="6" name="Text 4"/>
+          <p:cNvSpPr/>
+          <p:nvPr/>
+        </p:nvSpPr>
+        <p:spPr>
+          <a:xfrm>
+            <a:off x="1005840" y="2103120"/>
+            <a:ext cx="365760" cy="365760"/>
+          </a:xfrm>
+          <a:prstGeom prst="rect">
+            <a:avLst/>
+          </a:prstGeom>
+          <a:noFill/>
+          <a:ln/>
+        </p:spPr>
+        <p:txBody>
+          <a:bodyPr wrap="square" lIns="0" tIns="0" rIns="0" bIns="0" rtlCol="0" anchor="ctr"/>
+          <a:lstStyle/>
+          <a:p>
+            <a:pPr algn="ctr" indent="0" marL="0">
+              <a:buNone/>
+            </a:pPr>
+            <a:r>
+              <a:rPr lang="en-US" sz="1500" b="1" dirty="0">
+                <a:solidFill>
+                  <a:srgbClr val="FFFFFF"/>
+                </a:solidFill>
+                <a:latin typeface="Calibri" pitchFamily="34" charset="0"/>
+                <a:ea typeface="Calibri" pitchFamily="34" charset="-122"/>
+                <a:cs typeface="Calibri" pitchFamily="34" charset="-120"/>
+              </a:rPr>
+              <a:t>1</a:t>
+            </a:r>
+            <a:endParaRPr lang="en-US" sz="1500" dirty="0"/>
+          </a:p>
+        </p:txBody>
+      </p:sp>
+      <p:sp>
+        <p:nvSpPr>
+          <p:cNvPr id="7" name="Text 5"/>
+          <p:cNvSpPr/>
+          <p:nvPr/>
+        </p:nvSpPr>
+        <p:spPr>
+          <a:xfrm>
+            <a:off x="1508760" y="2103120"/>
+            <a:ext cx="2331720" cy="365760"/>
+          </a:xfrm>
+          <a:prstGeom prst="rect">
+            <a:avLst/>
+          </a:prstGeom>
+          <a:noFill/>
+          <a:ln/>
+        </p:spPr>
+        <p:txBody>
+          <a:bodyPr wrap="square" lIns="0" tIns="0" rIns="0" bIns="0" rtlCol="0" anchor="ctr"/>
+          <a:lstStyle/>
+          <a:p>
+            <a:pPr indent="0" marL="0">
+              <a:buNone/>
+            </a:pPr>
+            <a:r>
+              <a:rPr lang="en-US" sz="1450" b="1" dirty="0">
+                <a:solidFill>
+                  <a:srgbClr val="0B2F42"/>
+                </a:solidFill>
+                <a:latin typeface="Calibri" pitchFamily="34" charset="0"/>
+                <a:ea typeface="Calibri" pitchFamily="34" charset="-122"/>
+                <a:cs typeface="Calibri" pitchFamily="34" charset="-120"/>
+              </a:rPr>
+              <a:t>Weight each match</a:t>
+            </a:r>
+            <a:endParaRPr lang="en-US" sz="1450" dirty="0"/>
+          </a:p>
+        </p:txBody>
+      </p:sp>
+      <p:sp>
+        <p:nvSpPr>
+          <p:cNvPr id="8" name="Shape 6"/>
+          <p:cNvSpPr/>
+          <p:nvPr/>
+        </p:nvSpPr>
+        <p:spPr>
+          <a:xfrm>
+            <a:off x="1005840" y="2679192"/>
+            <a:ext cx="118872" cy="118872"/>
+          </a:xfrm>
+          <a:prstGeom prst="ellipse">
+            <a:avLst/>
+          </a:prstGeom>
+          <a:solidFill>
             <a:srgbClr val="E24B4A"/>
           </a:solidFill>
           <a:ln/>
         </p:spPr>
       </p:sp>
-      <p:pic>
-        <p:nvPicPr>
-          <p:cNvPr id="5" name="Image 0" descr="icon-bug.png">    </p:cNvPr>
-          <p:cNvPicPr>
-            <a:picLocks noChangeAspect="1"/>
-          </p:cNvPicPr>
-          <p:nvPr/>
-        </p:nvPicPr>
-        <p:blipFill>
-          <a:blip r:embed="rId1"/>
-          <a:stretch>
-            <a:fillRect/>
-          </a:stretch>
-        </p:blipFill>
-        <p:spPr>
-          <a:xfrm>
-            <a:off x="810890" y="2411090"/>
-            <a:ext cx="408188" cy="408188"/>
-          </a:xfrm>
-          <a:prstGeom prst="rect">
-            <a:avLst/>
-          </a:prstGeom>
-        </p:spPr>
-      </p:pic>
-      <p:sp>
-        <p:nvSpPr>
-          <p:cNvPr id="6" name="Text 3"/>
-          <p:cNvSpPr/>
-          <p:nvPr/>
-        </p:nvSpPr>
-        <p:spPr>
-          <a:xfrm>
-            <a:off x="1527048" y="2295144"/>
-            <a:ext cx="9811512" cy="320040"/>
-          </a:xfrm>
-          <a:prstGeom prst="rect">
-            <a:avLst/>
-          </a:prstGeom>
-          <a:noFill/>
-          <a:ln/>
-        </p:spPr>
-        <p:txBody>
-          <a:bodyPr wrap="square" lIns="0" tIns="0" rIns="0" bIns="0" rtlCol="0" anchor="ctr"/>
-          <a:lstStyle/>
-          <a:p>
-            <a:pPr indent="0" marL="0">
-              <a:buNone/>
-            </a:pPr>
-            <a:r>
-              <a:rPr lang="en-US" sz="1600" b="1" dirty="0">
+      <p:sp>
+        <p:nvSpPr>
+          <p:cNvPr id="9" name="Text 7"/>
+          <p:cNvSpPr/>
+          <p:nvPr/>
+        </p:nvSpPr>
+        <p:spPr>
+          <a:xfrm>
+            <a:off x="1216152" y="2560320"/>
+            <a:ext cx="1691640" cy="274320"/>
+          </a:xfrm>
+          <a:prstGeom prst="rect">
+            <a:avLst/>
+          </a:prstGeom>
+          <a:noFill/>
+          <a:ln/>
+        </p:spPr>
+        <p:txBody>
+          <a:bodyPr wrap="square" lIns="0" tIns="0" rIns="0" bIns="0" rtlCol="0" anchor="ctr"/>
+          <a:lstStyle/>
+          <a:p>
+            <a:pPr indent="0" marL="0">
+              <a:buNone/>
+            </a:pPr>
+            <a:r>
+              <a:rPr lang="en-US" sz="1150" dirty="0">
                 <a:solidFill>
                   <a:srgbClr val="1F2933"/>
                 </a:solidFill>
@@ -10467,31 +11167,680 @@
                 <a:ea typeface="Calibri" pitchFamily="34" charset="-122"/>
                 <a:cs typeface="Calibri" pitchFamily="34" charset="-120"/>
               </a:rPr>
-              <a:t>Silent zero-database bug</a:t>
-            </a:r>
-            <a:endParaRPr lang="en-US" sz="1600" dirty="0"/>
-          </a:p>
-        </p:txBody>
-      </p:sp>
-      <p:sp>
-        <p:nvSpPr>
-          <p:cNvPr id="7" name="Text 4"/>
-          <p:cNvSpPr/>
-          <p:nvPr/>
-        </p:nvSpPr>
-        <p:spPr>
-          <a:xfrm>
-            <a:off x="1527048" y="2624328"/>
-            <a:ext cx="9811512" cy="685800"/>
-          </a:xfrm>
-          <a:prstGeom prst="rect">
-            <a:avLst/>
-          </a:prstGeom>
-          <a:noFill/>
-          <a:ln/>
-        </p:spPr>
-        <p:txBody>
-          <a:bodyPr wrap="square" lIns="0" tIns="0" rIns="0" bIns="0" rtlCol="0" anchor="t"/>
+              <a:t>Banned</a:t>
+            </a:r>
+            <a:endParaRPr lang="en-US" sz="1150" dirty="0"/>
+          </a:p>
+        </p:txBody>
+      </p:sp>
+      <p:sp>
+        <p:nvSpPr>
+          <p:cNvPr id="10" name="Text 8"/>
+          <p:cNvSpPr/>
+          <p:nvPr/>
+        </p:nvSpPr>
+        <p:spPr>
+          <a:xfrm>
+            <a:off x="3429000" y="2560320"/>
+            <a:ext cx="365760" cy="274320"/>
+          </a:xfrm>
+          <a:prstGeom prst="rect">
+            <a:avLst/>
+          </a:prstGeom>
+          <a:noFill/>
+          <a:ln/>
+        </p:spPr>
+        <p:txBody>
+          <a:bodyPr wrap="square" lIns="0" tIns="0" rIns="0" bIns="0" rtlCol="0" anchor="ctr"/>
+          <a:lstStyle/>
+          <a:p>
+            <a:pPr algn="r" indent="0" marL="0">
+              <a:buNone/>
+            </a:pPr>
+            <a:r>
+              <a:rPr lang="en-US" sz="1150" b="1" dirty="0">
+                <a:solidFill>
+                  <a:srgbClr val="0B2F42"/>
+                </a:solidFill>
+                <a:latin typeface="Calibri" pitchFamily="34" charset="0"/>
+                <a:ea typeface="Calibri" pitchFamily="34" charset="-122"/>
+                <a:cs typeface="Calibri" pitchFamily="34" charset="-120"/>
+              </a:rPr>
+              <a:t>100</a:t>
+            </a:r>
+            <a:endParaRPr lang="en-US" sz="1150" dirty="0"/>
+          </a:p>
+        </p:txBody>
+      </p:sp>
+      <p:sp>
+        <p:nvSpPr>
+          <p:cNvPr id="11" name="Shape 9"/>
+          <p:cNvSpPr/>
+          <p:nvPr/>
+        </p:nvSpPr>
+        <p:spPr>
+          <a:xfrm>
+            <a:off x="1005840" y="2926080"/>
+            <a:ext cx="118872" cy="118872"/>
+          </a:xfrm>
+          <a:prstGeom prst="ellipse">
+            <a:avLst/>
+          </a:prstGeom>
+          <a:solidFill>
+            <a:srgbClr val="EF9F27"/>
+          </a:solidFill>
+          <a:ln/>
+        </p:spPr>
+      </p:sp>
+      <p:sp>
+        <p:nvSpPr>
+          <p:cNvPr id="12" name="Text 10"/>
+          <p:cNvSpPr/>
+          <p:nvPr/>
+        </p:nvSpPr>
+        <p:spPr>
+          <a:xfrm>
+            <a:off x="1216152" y="2807208"/>
+            <a:ext cx="1691640" cy="274320"/>
+          </a:xfrm>
+          <a:prstGeom prst="rect">
+            <a:avLst/>
+          </a:prstGeom>
+          <a:noFill/>
+          <a:ln/>
+        </p:spPr>
+        <p:txBody>
+          <a:bodyPr wrap="square" lIns="0" tIns="0" rIns="0" bIns="0" rtlCol="0" anchor="ctr"/>
+          <a:lstStyle/>
+          <a:p>
+            <a:pPr indent="0" marL="0">
+              <a:buNone/>
+            </a:pPr>
+            <a:r>
+              <a:rPr lang="en-US" sz="1150" dirty="0">
+                <a:solidFill>
+                  <a:srgbClr val="1F2933"/>
+                </a:solidFill>
+                <a:latin typeface="Calibri" pitchFamily="34" charset="0"/>
+                <a:ea typeface="Calibri" pitchFamily="34" charset="-122"/>
+                <a:cs typeface="Calibri" pitchFamily="34" charset="-120"/>
+              </a:rPr>
+              <a:t>Allergen</a:t>
+            </a:r>
+            <a:endParaRPr lang="en-US" sz="1150" dirty="0"/>
+          </a:p>
+        </p:txBody>
+      </p:sp>
+      <p:sp>
+        <p:nvSpPr>
+          <p:cNvPr id="13" name="Text 11"/>
+          <p:cNvSpPr/>
+          <p:nvPr/>
+        </p:nvSpPr>
+        <p:spPr>
+          <a:xfrm>
+            <a:off x="3429000" y="2807208"/>
+            <a:ext cx="365760" cy="274320"/>
+          </a:xfrm>
+          <a:prstGeom prst="rect">
+            <a:avLst/>
+          </a:prstGeom>
+          <a:noFill/>
+          <a:ln/>
+        </p:spPr>
+        <p:txBody>
+          <a:bodyPr wrap="square" lIns="0" tIns="0" rIns="0" bIns="0" rtlCol="0" anchor="ctr"/>
+          <a:lstStyle/>
+          <a:p>
+            <a:pPr algn="r" indent="0" marL="0">
+              <a:buNone/>
+            </a:pPr>
+            <a:r>
+              <a:rPr lang="en-US" sz="1150" b="1" dirty="0">
+                <a:solidFill>
+                  <a:srgbClr val="0B2F42"/>
+                </a:solidFill>
+                <a:latin typeface="Calibri" pitchFamily="34" charset="0"/>
+                <a:ea typeface="Calibri" pitchFamily="34" charset="-122"/>
+                <a:cs typeface="Calibri" pitchFamily="34" charset="-120"/>
+              </a:rPr>
+              <a:t>80</a:t>
+            </a:r>
+            <a:endParaRPr lang="en-US" sz="1150" dirty="0"/>
+          </a:p>
+        </p:txBody>
+      </p:sp>
+      <p:sp>
+        <p:nvSpPr>
+          <p:cNvPr id="14" name="Shape 12"/>
+          <p:cNvSpPr/>
+          <p:nvPr/>
+        </p:nvSpPr>
+        <p:spPr>
+          <a:xfrm>
+            <a:off x="1005840" y="3172968"/>
+            <a:ext cx="118872" cy="118872"/>
+          </a:xfrm>
+          <a:prstGeom prst="ellipse">
+            <a:avLst/>
+          </a:prstGeom>
+          <a:solidFill>
+            <a:srgbClr val="BA7517"/>
+          </a:solidFill>
+          <a:ln/>
+        </p:spPr>
+      </p:sp>
+      <p:sp>
+        <p:nvSpPr>
+          <p:cNvPr id="15" name="Text 13"/>
+          <p:cNvSpPr/>
+          <p:nvPr/>
+        </p:nvSpPr>
+        <p:spPr>
+          <a:xfrm>
+            <a:off x="1216152" y="3054096"/>
+            <a:ext cx="1691640" cy="274320"/>
+          </a:xfrm>
+          <a:prstGeom prst="rect">
+            <a:avLst/>
+          </a:prstGeom>
+          <a:noFill/>
+          <a:ln/>
+        </p:spPr>
+        <p:txBody>
+          <a:bodyPr wrap="square" lIns="0" tIns="0" rIns="0" bIns="0" rtlCol="0" anchor="ctr"/>
+          <a:lstStyle/>
+          <a:p>
+            <a:pPr indent="0" marL="0">
+              <a:buNone/>
+            </a:pPr>
+            <a:r>
+              <a:rPr lang="en-US" sz="1150" dirty="0">
+                <a:solidFill>
+                  <a:srgbClr val="1F2933"/>
+                </a:solidFill>
+                <a:latin typeface="Calibri" pitchFamily="34" charset="0"/>
+                <a:ea typeface="Calibri" pitchFamily="34" charset="-122"/>
+                <a:cs typeface="Calibri" pitchFamily="34" charset="-120"/>
+              </a:rPr>
+              <a:t>Concern</a:t>
+            </a:r>
+            <a:endParaRPr lang="en-US" sz="1150" dirty="0"/>
+          </a:p>
+        </p:txBody>
+      </p:sp>
+      <p:sp>
+        <p:nvSpPr>
+          <p:cNvPr id="16" name="Text 14"/>
+          <p:cNvSpPr/>
+          <p:nvPr/>
+        </p:nvSpPr>
+        <p:spPr>
+          <a:xfrm>
+            <a:off x="3429000" y="3054096"/>
+            <a:ext cx="365760" cy="274320"/>
+          </a:xfrm>
+          <a:prstGeom prst="rect">
+            <a:avLst/>
+          </a:prstGeom>
+          <a:noFill/>
+          <a:ln/>
+        </p:spPr>
+        <p:txBody>
+          <a:bodyPr wrap="square" lIns="0" tIns="0" rIns="0" bIns="0" rtlCol="0" anchor="ctr"/>
+          <a:lstStyle/>
+          <a:p>
+            <a:pPr algn="r" indent="0" marL="0">
+              <a:buNone/>
+            </a:pPr>
+            <a:r>
+              <a:rPr lang="en-US" sz="1150" b="1" dirty="0">
+                <a:solidFill>
+                  <a:srgbClr val="0B2F42"/>
+                </a:solidFill>
+                <a:latin typeface="Calibri" pitchFamily="34" charset="0"/>
+                <a:ea typeface="Calibri" pitchFamily="34" charset="-122"/>
+                <a:cs typeface="Calibri" pitchFamily="34" charset="-120"/>
+              </a:rPr>
+              <a:t>60</a:t>
+            </a:r>
+            <a:endParaRPr lang="en-US" sz="1150" dirty="0"/>
+          </a:p>
+        </p:txBody>
+      </p:sp>
+      <p:sp>
+        <p:nvSpPr>
+          <p:cNvPr id="17" name="Shape 15"/>
+          <p:cNvSpPr/>
+          <p:nvPr/>
+        </p:nvSpPr>
+        <p:spPr>
+          <a:xfrm>
+            <a:off x="1005840" y="3419856"/>
+            <a:ext cx="118872" cy="118872"/>
+          </a:xfrm>
+          <a:prstGeom prst="ellipse">
+            <a:avLst/>
+          </a:prstGeom>
+          <a:solidFill>
+            <a:srgbClr val="378ADD"/>
+          </a:solidFill>
+          <a:ln/>
+        </p:spPr>
+      </p:sp>
+      <p:sp>
+        <p:nvSpPr>
+          <p:cNvPr id="18" name="Text 16"/>
+          <p:cNvSpPr/>
+          <p:nvPr/>
+        </p:nvSpPr>
+        <p:spPr>
+          <a:xfrm>
+            <a:off x="1216152" y="3300984"/>
+            <a:ext cx="1691640" cy="274320"/>
+          </a:xfrm>
+          <a:prstGeom prst="rect">
+            <a:avLst/>
+          </a:prstGeom>
+          <a:noFill/>
+          <a:ln/>
+        </p:spPr>
+        <p:txBody>
+          <a:bodyPr wrap="square" lIns="0" tIns="0" rIns="0" bIns="0" rtlCol="0" anchor="ctr"/>
+          <a:lstStyle/>
+          <a:p>
+            <a:pPr indent="0" marL="0">
+              <a:buNone/>
+            </a:pPr>
+            <a:r>
+              <a:rPr lang="en-US" sz="1150" dirty="0">
+                <a:solidFill>
+                  <a:srgbClr val="1F2933"/>
+                </a:solidFill>
+                <a:latin typeface="Calibri" pitchFamily="34" charset="0"/>
+                <a:ea typeface="Calibri" pitchFamily="34" charset="-122"/>
+                <a:cs typeface="Calibri" pitchFamily="34" charset="-120"/>
+              </a:rPr>
+              <a:t>Review</a:t>
+            </a:r>
+            <a:endParaRPr lang="en-US" sz="1150" dirty="0"/>
+          </a:p>
+        </p:txBody>
+      </p:sp>
+      <p:sp>
+        <p:nvSpPr>
+          <p:cNvPr id="19" name="Text 17"/>
+          <p:cNvSpPr/>
+          <p:nvPr/>
+        </p:nvSpPr>
+        <p:spPr>
+          <a:xfrm>
+            <a:off x="3429000" y="3300984"/>
+            <a:ext cx="365760" cy="274320"/>
+          </a:xfrm>
+          <a:prstGeom prst="rect">
+            <a:avLst/>
+          </a:prstGeom>
+          <a:noFill/>
+          <a:ln/>
+        </p:spPr>
+        <p:txBody>
+          <a:bodyPr wrap="square" lIns="0" tIns="0" rIns="0" bIns="0" rtlCol="0" anchor="ctr"/>
+          <a:lstStyle/>
+          <a:p>
+            <a:pPr algn="r" indent="0" marL="0">
+              <a:buNone/>
+            </a:pPr>
+            <a:r>
+              <a:rPr lang="en-US" sz="1150" b="1" dirty="0">
+                <a:solidFill>
+                  <a:srgbClr val="0B2F42"/>
+                </a:solidFill>
+                <a:latin typeface="Calibri" pitchFamily="34" charset="0"/>
+                <a:ea typeface="Calibri" pitchFamily="34" charset="-122"/>
+                <a:cs typeface="Calibri" pitchFamily="34" charset="-120"/>
+              </a:rPr>
+              <a:t>40</a:t>
+            </a:r>
+            <a:endParaRPr lang="en-US" sz="1150" dirty="0"/>
+          </a:p>
+        </p:txBody>
+      </p:sp>
+      <p:sp>
+        <p:nvSpPr>
+          <p:cNvPr id="20" name="Shape 18"/>
+          <p:cNvSpPr/>
+          <p:nvPr/>
+        </p:nvSpPr>
+        <p:spPr>
+          <a:xfrm>
+            <a:off x="1005840" y="3666744"/>
+            <a:ext cx="118872" cy="118872"/>
+          </a:xfrm>
+          <a:prstGeom prst="ellipse">
+            <a:avLst/>
+          </a:prstGeom>
+          <a:solidFill>
+            <a:srgbClr val="7F77DD"/>
+          </a:solidFill>
+          <a:ln/>
+        </p:spPr>
+      </p:sp>
+      <p:sp>
+        <p:nvSpPr>
+          <p:cNvPr id="21" name="Text 19"/>
+          <p:cNvSpPr/>
+          <p:nvPr/>
+        </p:nvSpPr>
+        <p:spPr>
+          <a:xfrm>
+            <a:off x="1216152" y="3547872"/>
+            <a:ext cx="1691640" cy="274320"/>
+          </a:xfrm>
+          <a:prstGeom prst="rect">
+            <a:avLst/>
+          </a:prstGeom>
+          <a:noFill/>
+          <a:ln/>
+        </p:spPr>
+        <p:txBody>
+          <a:bodyPr wrap="square" lIns="0" tIns="0" rIns="0" bIns="0" rtlCol="0" anchor="ctr"/>
+          <a:lstStyle/>
+          <a:p>
+            <a:pPr indent="0" marL="0">
+              <a:buNone/>
+            </a:pPr>
+            <a:r>
+              <a:rPr lang="en-US" sz="1150" dirty="0">
+                <a:solidFill>
+                  <a:srgbClr val="1F2933"/>
+                </a:solidFill>
+                <a:latin typeface="Calibri" pitchFamily="34" charset="0"/>
+                <a:ea typeface="Calibri" pitchFamily="34" charset="-122"/>
+                <a:cs typeface="Calibri" pitchFamily="34" charset="-120"/>
+              </a:rPr>
+              <a:t>Secret GRAS</a:t>
+            </a:r>
+            <a:endParaRPr lang="en-US" sz="1150" dirty="0"/>
+          </a:p>
+        </p:txBody>
+      </p:sp>
+      <p:sp>
+        <p:nvSpPr>
+          <p:cNvPr id="22" name="Text 20"/>
+          <p:cNvSpPr/>
+          <p:nvPr/>
+        </p:nvSpPr>
+        <p:spPr>
+          <a:xfrm>
+            <a:off x="3429000" y="3547872"/>
+            <a:ext cx="365760" cy="274320"/>
+          </a:xfrm>
+          <a:prstGeom prst="rect">
+            <a:avLst/>
+          </a:prstGeom>
+          <a:noFill/>
+          <a:ln/>
+        </p:spPr>
+        <p:txBody>
+          <a:bodyPr wrap="square" lIns="0" tIns="0" rIns="0" bIns="0" rtlCol="0" anchor="ctr"/>
+          <a:lstStyle/>
+          <a:p>
+            <a:pPr algn="r" indent="0" marL="0">
+              <a:buNone/>
+            </a:pPr>
+            <a:r>
+              <a:rPr lang="en-US" sz="1150" b="1" dirty="0">
+                <a:solidFill>
+                  <a:srgbClr val="0B2F42"/>
+                </a:solidFill>
+                <a:latin typeface="Calibri" pitchFamily="34" charset="0"/>
+                <a:ea typeface="Calibri" pitchFamily="34" charset="-122"/>
+                <a:cs typeface="Calibri" pitchFamily="34" charset="-120"/>
+              </a:rPr>
+              <a:t>35</a:t>
+            </a:r>
+            <a:endParaRPr lang="en-US" sz="1150" dirty="0"/>
+          </a:p>
+        </p:txBody>
+      </p:sp>
+      <p:sp>
+        <p:nvSpPr>
+          <p:cNvPr id="23" name="Shape 21"/>
+          <p:cNvSpPr/>
+          <p:nvPr/>
+        </p:nvSpPr>
+        <p:spPr>
+          <a:xfrm>
+            <a:off x="1005840" y="3913632"/>
+            <a:ext cx="118872" cy="118872"/>
+          </a:xfrm>
+          <a:prstGeom prst="ellipse">
+            <a:avLst/>
+          </a:prstGeom>
+          <a:solidFill>
+            <a:srgbClr val="34C759"/>
+          </a:solidFill>
+          <a:ln/>
+        </p:spPr>
+      </p:sp>
+      <p:sp>
+        <p:nvSpPr>
+          <p:cNvPr id="24" name="Text 22"/>
+          <p:cNvSpPr/>
+          <p:nvPr/>
+        </p:nvSpPr>
+        <p:spPr>
+          <a:xfrm>
+            <a:off x="1216152" y="3794760"/>
+            <a:ext cx="1691640" cy="274320"/>
+          </a:xfrm>
+          <a:prstGeom prst="rect">
+            <a:avLst/>
+          </a:prstGeom>
+          <a:noFill/>
+          <a:ln/>
+        </p:spPr>
+        <p:txBody>
+          <a:bodyPr wrap="square" lIns="0" tIns="0" rIns="0" bIns="0" rtlCol="0" anchor="ctr"/>
+          <a:lstStyle/>
+          <a:p>
+            <a:pPr indent="0" marL="0">
+              <a:buNone/>
+            </a:pPr>
+            <a:r>
+              <a:rPr lang="en-US" sz="1150" dirty="0">
+                <a:solidFill>
+                  <a:srgbClr val="1F2933"/>
+                </a:solidFill>
+                <a:latin typeface="Calibri" pitchFamily="34" charset="0"/>
+                <a:ea typeface="Calibri" pitchFamily="34" charset="-122"/>
+                <a:cs typeface="Calibri" pitchFamily="34" charset="-120"/>
+              </a:rPr>
+              <a:t>Safe</a:t>
+            </a:r>
+            <a:endParaRPr lang="en-US" sz="1150" dirty="0"/>
+          </a:p>
+        </p:txBody>
+      </p:sp>
+      <p:sp>
+        <p:nvSpPr>
+          <p:cNvPr id="25" name="Text 23"/>
+          <p:cNvSpPr/>
+          <p:nvPr/>
+        </p:nvSpPr>
+        <p:spPr>
+          <a:xfrm>
+            <a:off x="3429000" y="3794760"/>
+            <a:ext cx="365760" cy="274320"/>
+          </a:xfrm>
+          <a:prstGeom prst="rect">
+            <a:avLst/>
+          </a:prstGeom>
+          <a:noFill/>
+          <a:ln/>
+        </p:spPr>
+        <p:txBody>
+          <a:bodyPr wrap="square" lIns="0" tIns="0" rIns="0" bIns="0" rtlCol="0" anchor="ctr"/>
+          <a:lstStyle/>
+          <a:p>
+            <a:pPr algn="r" indent="0" marL="0">
+              <a:buNone/>
+            </a:pPr>
+            <a:r>
+              <a:rPr lang="en-US" sz="1150" b="1" dirty="0">
+                <a:solidFill>
+                  <a:srgbClr val="0B2F42"/>
+                </a:solidFill>
+                <a:latin typeface="Calibri" pitchFamily="34" charset="0"/>
+                <a:ea typeface="Calibri" pitchFamily="34" charset="-122"/>
+                <a:cs typeface="Calibri" pitchFamily="34" charset="-120"/>
+              </a:rPr>
+              <a:t>0</a:t>
+            </a:r>
+            <a:endParaRPr lang="en-US" sz="1150" dirty="0"/>
+          </a:p>
+        </p:txBody>
+      </p:sp>
+      <p:sp>
+        <p:nvSpPr>
+          <p:cNvPr id="26" name="Shape 24"/>
+          <p:cNvSpPr/>
+          <p:nvPr/>
+        </p:nvSpPr>
+        <p:spPr>
+          <a:xfrm>
+            <a:off x="4389120" y="1828800"/>
+            <a:ext cx="3337560" cy="2560320"/>
+          </a:xfrm>
+          <a:prstGeom prst="roundRect">
+            <a:avLst>
+              <a:gd name="adj" fmla="val 2857"/>
+            </a:avLst>
+          </a:prstGeom>
+          <a:solidFill>
+            <a:srgbClr val="EAF3F6"/>
+          </a:solidFill>
+          <a:ln/>
+        </p:spPr>
+      </p:sp>
+      <p:sp>
+        <p:nvSpPr>
+          <p:cNvPr id="27" name="Shape 25"/>
+          <p:cNvSpPr/>
+          <p:nvPr/>
+        </p:nvSpPr>
+        <p:spPr>
+          <a:xfrm>
+            <a:off x="4663440" y="2103120"/>
+            <a:ext cx="365760" cy="365760"/>
+          </a:xfrm>
+          <a:prstGeom prst="ellipse">
+            <a:avLst/>
+          </a:prstGeom>
+          <a:solidFill>
+            <a:srgbClr val="0B2F42"/>
+          </a:solidFill>
+          <a:ln/>
+        </p:spPr>
+      </p:sp>
+      <p:sp>
+        <p:nvSpPr>
+          <p:cNvPr id="28" name="Text 26"/>
+          <p:cNvSpPr/>
+          <p:nvPr/>
+        </p:nvSpPr>
+        <p:spPr>
+          <a:xfrm>
+            <a:off x="4663440" y="2103120"/>
+            <a:ext cx="365760" cy="365760"/>
+          </a:xfrm>
+          <a:prstGeom prst="rect">
+            <a:avLst/>
+          </a:prstGeom>
+          <a:noFill/>
+          <a:ln/>
+        </p:spPr>
+        <p:txBody>
+          <a:bodyPr wrap="square" lIns="0" tIns="0" rIns="0" bIns="0" rtlCol="0" anchor="ctr"/>
+          <a:lstStyle/>
+          <a:p>
+            <a:pPr algn="ctr" indent="0" marL="0">
+              <a:buNone/>
+            </a:pPr>
+            <a:r>
+              <a:rPr lang="en-US" sz="1500" b="1" dirty="0">
+                <a:solidFill>
+                  <a:srgbClr val="FFFFFF"/>
+                </a:solidFill>
+                <a:latin typeface="Calibri" pitchFamily="34" charset="0"/>
+                <a:ea typeface="Calibri" pitchFamily="34" charset="-122"/>
+                <a:cs typeface="Calibri" pitchFamily="34" charset="-120"/>
+              </a:rPr>
+              <a:t>2</a:t>
+            </a:r>
+            <a:endParaRPr lang="en-US" sz="1500" dirty="0"/>
+          </a:p>
+        </p:txBody>
+      </p:sp>
+      <p:sp>
+        <p:nvSpPr>
+          <p:cNvPr id="29" name="Text 27"/>
+          <p:cNvSpPr/>
+          <p:nvPr/>
+        </p:nvSpPr>
+        <p:spPr>
+          <a:xfrm>
+            <a:off x="5166360" y="2103120"/>
+            <a:ext cx="2331720" cy="365760"/>
+          </a:xfrm>
+          <a:prstGeom prst="rect">
+            <a:avLst/>
+          </a:prstGeom>
+          <a:noFill/>
+          <a:ln/>
+        </p:spPr>
+        <p:txBody>
+          <a:bodyPr wrap="square" lIns="0" tIns="0" rIns="0" bIns="0" rtlCol="0" anchor="ctr"/>
+          <a:lstStyle/>
+          <a:p>
+            <a:pPr indent="0" marL="0">
+              <a:buNone/>
+            </a:pPr>
+            <a:r>
+              <a:rPr lang="en-US" sz="1450" b="1" dirty="0">
+                <a:solidFill>
+                  <a:srgbClr val="0B2F42"/>
+                </a:solidFill>
+                <a:latin typeface="Calibri" pitchFamily="34" charset="0"/>
+                <a:ea typeface="Calibri" pitchFamily="34" charset="-122"/>
+                <a:cs typeface="Calibri" pitchFamily="34" charset="-120"/>
+              </a:rPr>
+              <a:t>Average, then adjust</a:t>
+            </a:r>
+            <a:endParaRPr lang="en-US" sz="1450" dirty="0"/>
+          </a:p>
+        </p:txBody>
+      </p:sp>
+      <p:sp>
+        <p:nvSpPr>
+          <p:cNvPr id="30" name="Text 28"/>
+          <p:cNvSpPr/>
+          <p:nvPr/>
+        </p:nvSpPr>
+        <p:spPr>
+          <a:xfrm>
+            <a:off x="4663440" y="2697480"/>
+            <a:ext cx="2788920" cy="274320"/>
+          </a:xfrm>
+          <a:prstGeom prst="rect">
+            <a:avLst/>
+          </a:prstGeom>
+          <a:noFill/>
+          <a:ln/>
+        </p:spPr>
+        <p:txBody>
+          <a:bodyPr wrap="square" lIns="0" tIns="0" rIns="0" bIns="0" rtlCol="0" anchor="ctr"/>
           <a:lstStyle/>
           <a:p>
             <a:pPr indent="0" marL="0">
@@ -10500,13 +11849,208 @@
             <a:r>
               <a:rPr lang="en-US" sz="1250" dirty="0">
                 <a:solidFill>
+                  <a:srgbClr val="0B2F42"/>
+                </a:solidFill>
+                <a:latin typeface="Calibri" pitchFamily="34" charset="0"/>
+                <a:ea typeface="Calibri" pitchFamily="34" charset="-122"/>
+                <a:cs typeface="Calibri" pitchFamily="34" charset="-120"/>
+              </a:rPr>
+              <a:t>round( average of matched weights )</a:t>
+            </a:r>
+            <a:endParaRPr lang="en-US" sz="1250" dirty="0"/>
+          </a:p>
+        </p:txBody>
+      </p:sp>
+      <p:sp>
+        <p:nvSpPr>
+          <p:cNvPr id="31" name="Text 29"/>
+          <p:cNvSpPr/>
+          <p:nvPr/>
+        </p:nvSpPr>
+        <p:spPr>
+          <a:xfrm>
+            <a:off x="4663440" y="3026664"/>
+            <a:ext cx="2788920" cy="274320"/>
+          </a:xfrm>
+          <a:prstGeom prst="rect">
+            <a:avLst/>
+          </a:prstGeom>
+          <a:noFill/>
+          <a:ln/>
+        </p:spPr>
+        <p:txBody>
+          <a:bodyPr wrap="square" lIns="0" tIns="0" rIns="0" bIns="0" rtlCol="0" anchor="ctr"/>
+          <a:lstStyle/>
+          <a:p>
+            <a:pPr indent="0" marL="0">
+              <a:buNone/>
+            </a:pPr>
+            <a:r>
+              <a:rPr lang="en-US" sz="1500" b="1" dirty="0">
+                <a:solidFill>
+                  <a:srgbClr val="F2994A"/>
+                </a:solidFill>
+                <a:latin typeface="Calibri" pitchFamily="34" charset="0"/>
+                <a:ea typeface="Calibri" pitchFamily="34" charset="-122"/>
+                <a:cs typeface="Calibri" pitchFamily="34" charset="-120"/>
+              </a:rPr>
+              <a:t>+ 20</a:t>
+            </a:r>
+            <a:endParaRPr lang="en-US" sz="1500" dirty="0"/>
+          </a:p>
+        </p:txBody>
+      </p:sp>
+      <p:sp>
+        <p:nvSpPr>
+          <p:cNvPr id="32" name="Text 30"/>
+          <p:cNvSpPr/>
+          <p:nvPr/>
+        </p:nvSpPr>
+        <p:spPr>
+          <a:xfrm>
+            <a:off x="4663440" y="3282696"/>
+            <a:ext cx="2788920" cy="228600"/>
+          </a:xfrm>
+          <a:prstGeom prst="rect">
+            <a:avLst/>
+          </a:prstGeom>
+          <a:noFill/>
+          <a:ln/>
+        </p:spPr>
+        <p:txBody>
+          <a:bodyPr wrap="square" lIns="0" tIns="0" rIns="0" bIns="0" rtlCol="0" anchor="ctr"/>
+          <a:lstStyle/>
+          <a:p>
+            <a:pPr indent="0" marL="0">
+              <a:buNone/>
+            </a:pPr>
+            <a:r>
+              <a:rPr lang="en-US" sz="1050" dirty="0">
+                <a:solidFill>
                   <a:srgbClr val="5B6B79"/>
                 </a:solidFill>
                 <a:latin typeface="Calibri" pitchFamily="34" charset="0"/>
                 <a:ea typeface="Calibri" pitchFamily="34" charset="-122"/>
                 <a:cs typeface="Calibri" pitchFamily="34" charset="-120"/>
               </a:rPr>
-              <a:t>The bundled ingredients.json had a schema mismatch — the app was quietly running with zero ingredients loaded and no error shown. Root-caused by compiling the matching logic standalone and testing it directly against the actual bundled file.</a:t>
+              <a:t>if any match is Banned</a:t>
+            </a:r>
+            <a:endParaRPr lang="en-US" sz="1050" dirty="0"/>
+          </a:p>
+        </p:txBody>
+      </p:sp>
+      <p:sp>
+        <p:nvSpPr>
+          <p:cNvPr id="33" name="Text 31"/>
+          <p:cNvSpPr/>
+          <p:nvPr/>
+        </p:nvSpPr>
+        <p:spPr>
+          <a:xfrm>
+            <a:off x="4663440" y="3538728"/>
+            <a:ext cx="2788920" cy="274320"/>
+          </a:xfrm>
+          <a:prstGeom prst="rect">
+            <a:avLst/>
+          </a:prstGeom>
+          <a:noFill/>
+          <a:ln/>
+        </p:spPr>
+        <p:txBody>
+          <a:bodyPr wrap="square" lIns="0" tIns="0" rIns="0" bIns="0" rtlCol="0" anchor="ctr"/>
+          <a:lstStyle/>
+          <a:p>
+            <a:pPr indent="0" marL="0">
+              <a:buNone/>
+            </a:pPr>
+            <a:r>
+              <a:rPr lang="en-US" sz="1500" b="1" dirty="0">
+                <a:solidFill>
+                  <a:srgbClr val="F2994A"/>
+                </a:solidFill>
+                <a:latin typeface="Calibri" pitchFamily="34" charset="0"/>
+                <a:ea typeface="Calibri" pitchFamily="34" charset="-122"/>
+                <a:cs typeface="Calibri" pitchFamily="34" charset="-120"/>
+              </a:rPr>
+              <a:t>+ 15</a:t>
+            </a:r>
+            <a:endParaRPr lang="en-US" sz="1500" dirty="0"/>
+          </a:p>
+        </p:txBody>
+      </p:sp>
+      <p:sp>
+        <p:nvSpPr>
+          <p:cNvPr id="34" name="Text 32"/>
+          <p:cNvSpPr/>
+          <p:nvPr/>
+        </p:nvSpPr>
+        <p:spPr>
+          <a:xfrm>
+            <a:off x="4663440" y="3794760"/>
+            <a:ext cx="2788920" cy="228600"/>
+          </a:xfrm>
+          <a:prstGeom prst="rect">
+            <a:avLst/>
+          </a:prstGeom>
+          <a:noFill/>
+          <a:ln/>
+        </p:spPr>
+        <p:txBody>
+          <a:bodyPr wrap="square" lIns="0" tIns="0" rIns="0" bIns="0" rtlCol="0" anchor="ctr"/>
+          <a:lstStyle/>
+          <a:p>
+            <a:pPr indent="0" marL="0">
+              <a:buNone/>
+            </a:pPr>
+            <a:r>
+              <a:rPr lang="en-US" sz="1050" dirty="0">
+                <a:solidFill>
+                  <a:srgbClr val="5B6B79"/>
+                </a:solidFill>
+                <a:latin typeface="Calibri" pitchFamily="34" charset="0"/>
+                <a:ea typeface="Calibri" pitchFamily="34" charset="-122"/>
+                <a:cs typeface="Calibri" pitchFamily="34" charset="-120"/>
+              </a:rPr>
+              <a:t>if a match is your allergen</a:t>
+            </a:r>
+            <a:endParaRPr lang="en-US" sz="1050" dirty="0"/>
+          </a:p>
+        </p:txBody>
+      </p:sp>
+      <p:sp>
+        <p:nvSpPr>
+          <p:cNvPr id="35" name="Text 33"/>
+          <p:cNvSpPr/>
+          <p:nvPr/>
+        </p:nvSpPr>
+        <p:spPr>
+          <a:xfrm>
+            <a:off x="4663440" y="4050792"/>
+            <a:ext cx="2788920" cy="274320"/>
+          </a:xfrm>
+          <a:prstGeom prst="rect">
+            <a:avLst/>
+          </a:prstGeom>
+          <a:noFill/>
+          <a:ln/>
+        </p:spPr>
+        <p:txBody>
+          <a:bodyPr wrap="square" lIns="0" tIns="0" rIns="0" bIns="0" rtlCol="0" anchor="ctr"/>
+          <a:lstStyle/>
+          <a:p>
+            <a:pPr indent="0" marL="0">
+              <a:buNone/>
+            </a:pPr>
+            <a:r>
+              <a:rPr lang="en-US" sz="1250" dirty="0">
+                <a:solidFill>
+                  <a:srgbClr val="0B2F42"/>
+                </a:solidFill>
+                <a:latin typeface="Calibri" pitchFamily="34" charset="0"/>
+                <a:ea typeface="Calibri" pitchFamily="34" charset="-122"/>
+                <a:cs typeface="Calibri" pitchFamily="34" charset="-120"/>
+              </a:rPr>
+              <a:t>cap at 100</a:t>
             </a:r>
             <a:endParaRPr lang="en-US" sz="1250" dirty="0"/>
           </a:p>
@@ -10514,113 +12058,211 @@
       </p:sp>
       <p:sp>
         <p:nvSpPr>
-          <p:cNvPr id="8" name="Shape 5"/>
-          <p:cNvSpPr/>
-          <p:nvPr/>
-        </p:nvSpPr>
-        <p:spPr>
-          <a:xfrm>
-            <a:off x="731520" y="3703320"/>
-            <a:ext cx="566928" cy="566928"/>
+          <p:cNvPr id="36" name="Shape 34"/>
+          <p:cNvSpPr/>
+          <p:nvPr/>
+        </p:nvSpPr>
+        <p:spPr>
+          <a:xfrm>
+            <a:off x="8046720" y="1828800"/>
+            <a:ext cx="3337560" cy="2560320"/>
+          </a:xfrm>
+          <a:prstGeom prst="roundRect">
+            <a:avLst>
+              <a:gd name="adj" fmla="val 2857"/>
+            </a:avLst>
+          </a:prstGeom>
+          <a:solidFill>
+            <a:srgbClr val="EAF3F6"/>
+          </a:solidFill>
+          <a:ln/>
+        </p:spPr>
+      </p:sp>
+      <p:sp>
+        <p:nvSpPr>
+          <p:cNvPr id="37" name="Shape 35"/>
+          <p:cNvSpPr/>
+          <p:nvPr/>
+        </p:nvSpPr>
+        <p:spPr>
+          <a:xfrm>
+            <a:off x="8321040" y="2103120"/>
+            <a:ext cx="365760" cy="365760"/>
           </a:xfrm>
           <a:prstGeom prst="ellipse">
             <a:avLst/>
           </a:prstGeom>
           <a:solidFill>
-            <a:srgbClr val="1C7293"/>
-          </a:solidFill>
-          <a:ln/>
-        </p:spPr>
-      </p:sp>
-      <p:pic>
-        <p:nvPicPr>
-          <p:cNvPr id="9" name="Image 1" descr="icon-route.png">    </p:cNvPr>
-          <p:cNvPicPr>
-            <a:picLocks noChangeAspect="1"/>
-          </p:cNvPicPr>
-          <p:nvPr/>
-        </p:nvPicPr>
-        <p:blipFill>
-          <a:blip r:embed="rId2"/>
-          <a:stretch>
-            <a:fillRect/>
-          </a:stretch>
-        </p:blipFill>
-        <p:spPr>
-          <a:xfrm>
-            <a:off x="810890" y="3782690"/>
-            <a:ext cx="408188" cy="408188"/>
-          </a:xfrm>
-          <a:prstGeom prst="rect">
-            <a:avLst/>
-          </a:prstGeom>
-        </p:spPr>
-      </p:pic>
-      <p:sp>
-        <p:nvSpPr>
-          <p:cNvPr id="10" name="Text 6"/>
-          <p:cNvSpPr/>
-          <p:nvPr/>
-        </p:nvSpPr>
-        <p:spPr>
-          <a:xfrm>
-            <a:off x="1527048" y="3666744"/>
-            <a:ext cx="9811512" cy="320040"/>
-          </a:xfrm>
-          <a:prstGeom prst="rect">
-            <a:avLst/>
-          </a:prstGeom>
-          <a:noFill/>
-          <a:ln/>
-        </p:spPr>
-        <p:txBody>
-          <a:bodyPr wrap="square" lIns="0" tIns="0" rIns="0" bIns="0" rtlCol="0" anchor="ctr"/>
-          <a:lstStyle/>
-          <a:p>
-            <a:pPr indent="0" marL="0">
-              <a:buNone/>
-            </a:pPr>
-            <a:r>
-              <a:rPr lang="en-US" sz="1600" b="1" dirty="0">
-                <a:solidFill>
-                  <a:srgbClr val="1F2933"/>
-                </a:solidFill>
-                <a:latin typeface="Calibri" pitchFamily="34" charset="0"/>
-                <a:ea typeface="Calibri" pitchFamily="34" charset="-122"/>
-                <a:cs typeface="Calibri" pitchFamily="34" charset="-120"/>
-              </a:rPr>
-              <a:t>Multi-target iOS setup</a:t>
-            </a:r>
-            <a:endParaRPr lang="en-US" sz="1600" dirty="0"/>
-          </a:p>
-        </p:txBody>
-      </p:sp>
-      <p:sp>
-        <p:nvSpPr>
-          <p:cNvPr id="11" name="Text 7"/>
-          <p:cNvSpPr/>
-          <p:nvPr/>
-        </p:nvSpPr>
-        <p:spPr>
-          <a:xfrm>
-            <a:off x="1527048" y="3995928"/>
-            <a:ext cx="9811512" cy="685800"/>
-          </a:xfrm>
-          <a:prstGeom prst="rect">
-            <a:avLst/>
-          </a:prstGeom>
-          <a:noFill/>
-          <a:ln/>
-        </p:spPr>
-        <p:txBody>
-          <a:bodyPr wrap="square" lIns="0" tIns="0" rIns="0" bIns="0" rtlCol="0" anchor="t"/>
-          <a:lstStyle/>
-          <a:p>
-            <a:pPr indent="0" marL="0">
-              <a:buNone/>
-            </a:pPr>
-            <a:r>
-              <a:rPr lang="en-US" sz="1250" dirty="0">
+            <a:srgbClr val="0B2F42"/>
+          </a:solidFill>
+          <a:ln/>
+        </p:spPr>
+      </p:sp>
+      <p:sp>
+        <p:nvSpPr>
+          <p:cNvPr id="38" name="Text 36"/>
+          <p:cNvSpPr/>
+          <p:nvPr/>
+        </p:nvSpPr>
+        <p:spPr>
+          <a:xfrm>
+            <a:off x="8321040" y="2103120"/>
+            <a:ext cx="365760" cy="365760"/>
+          </a:xfrm>
+          <a:prstGeom prst="rect">
+            <a:avLst/>
+          </a:prstGeom>
+          <a:noFill/>
+          <a:ln/>
+        </p:spPr>
+        <p:txBody>
+          <a:bodyPr wrap="square" lIns="0" tIns="0" rIns="0" bIns="0" rtlCol="0" anchor="ctr"/>
+          <a:lstStyle/>
+          <a:p>
+            <a:pPr algn="ctr" indent="0" marL="0">
+              <a:buNone/>
+            </a:pPr>
+            <a:r>
+              <a:rPr lang="en-US" sz="1500" b="1" dirty="0">
+                <a:solidFill>
+                  <a:srgbClr val="FFFFFF"/>
+                </a:solidFill>
+                <a:latin typeface="Calibri" pitchFamily="34" charset="0"/>
+                <a:ea typeface="Calibri" pitchFamily="34" charset="-122"/>
+                <a:cs typeface="Calibri" pitchFamily="34" charset="-120"/>
+              </a:rPr>
+              <a:t>3</a:t>
+            </a:r>
+            <a:endParaRPr lang="en-US" sz="1500" dirty="0"/>
+          </a:p>
+        </p:txBody>
+      </p:sp>
+      <p:sp>
+        <p:nvSpPr>
+          <p:cNvPr id="39" name="Text 37"/>
+          <p:cNvSpPr/>
+          <p:nvPr/>
+        </p:nvSpPr>
+        <p:spPr>
+          <a:xfrm>
+            <a:off x="8823960" y="2103120"/>
+            <a:ext cx="2331720" cy="365760"/>
+          </a:xfrm>
+          <a:prstGeom prst="rect">
+            <a:avLst/>
+          </a:prstGeom>
+          <a:noFill/>
+          <a:ln/>
+        </p:spPr>
+        <p:txBody>
+          <a:bodyPr wrap="square" lIns="0" tIns="0" rIns="0" bIns="0" rtlCol="0" anchor="ctr"/>
+          <a:lstStyle/>
+          <a:p>
+            <a:pPr indent="0" marL="0">
+              <a:buNone/>
+            </a:pPr>
+            <a:r>
+              <a:rPr lang="en-US" sz="1450" b="1" dirty="0">
+                <a:solidFill>
+                  <a:srgbClr val="0B2F42"/>
+                </a:solidFill>
+                <a:latin typeface="Calibri" pitchFamily="34" charset="0"/>
+                <a:ea typeface="Calibri" pitchFamily="34" charset="-122"/>
+                <a:cs typeface="Calibri" pitchFamily="34" charset="-120"/>
+              </a:rPr>
+              <a:t>Map to a label</a:t>
+            </a:r>
+            <a:endParaRPr lang="en-US" sz="1450" dirty="0"/>
+          </a:p>
+        </p:txBody>
+      </p:sp>
+      <p:sp>
+        <p:nvSpPr>
+          <p:cNvPr id="40" name="Shape 38"/>
+          <p:cNvSpPr/>
+          <p:nvPr/>
+        </p:nvSpPr>
+        <p:spPr>
+          <a:xfrm>
+            <a:off x="8321040" y="2670048"/>
+            <a:ext cx="256032" cy="146304"/>
+          </a:xfrm>
+          <a:prstGeom prst="roundRect">
+            <a:avLst>
+              <a:gd name="adj" fmla="val 18750"/>
+            </a:avLst>
+          </a:prstGeom>
+          <a:solidFill>
+            <a:srgbClr val="34C759"/>
+          </a:solidFill>
+          <a:ln/>
+        </p:spPr>
+      </p:sp>
+      <p:sp>
+        <p:nvSpPr>
+          <p:cNvPr id="41" name="Text 39"/>
+          <p:cNvSpPr/>
+          <p:nvPr/>
+        </p:nvSpPr>
+        <p:spPr>
+          <a:xfrm>
+            <a:off x="8686800" y="2578608"/>
+            <a:ext cx="1280160" cy="274320"/>
+          </a:xfrm>
+          <a:prstGeom prst="rect">
+            <a:avLst/>
+          </a:prstGeom>
+          <a:noFill/>
+          <a:ln/>
+        </p:spPr>
+        <p:txBody>
+          <a:bodyPr wrap="square" lIns="0" tIns="0" rIns="0" bIns="0" rtlCol="0" anchor="ctr"/>
+          <a:lstStyle/>
+          <a:p>
+            <a:pPr indent="0" marL="0">
+              <a:buNone/>
+            </a:pPr>
+            <a:r>
+              <a:rPr lang="en-US" sz="1200" b="1" dirty="0">
+                <a:solidFill>
+                  <a:srgbClr val="0B2F42"/>
+                </a:solidFill>
+                <a:latin typeface="Calibri" pitchFamily="34" charset="0"/>
+                <a:ea typeface="Calibri" pitchFamily="34" charset="-122"/>
+                <a:cs typeface="Calibri" pitchFamily="34" charset="-120"/>
+              </a:rPr>
+              <a:t>Minimal</a:t>
+            </a:r>
+            <a:endParaRPr lang="en-US" sz="1200" dirty="0"/>
+          </a:p>
+        </p:txBody>
+      </p:sp>
+      <p:sp>
+        <p:nvSpPr>
+          <p:cNvPr id="42" name="Text 40"/>
+          <p:cNvSpPr/>
+          <p:nvPr/>
+        </p:nvSpPr>
+        <p:spPr>
+          <a:xfrm>
+            <a:off x="10378440" y="2578608"/>
+            <a:ext cx="731520" cy="274320"/>
+          </a:xfrm>
+          <a:prstGeom prst="rect">
+            <a:avLst/>
+          </a:prstGeom>
+          <a:noFill/>
+          <a:ln/>
+        </p:spPr>
+        <p:txBody>
+          <a:bodyPr wrap="square" lIns="0" tIns="0" rIns="0" bIns="0" rtlCol="0" anchor="ctr"/>
+          <a:lstStyle/>
+          <a:p>
+            <a:pPr algn="r" indent="0" marL="0">
+              <a:buNone/>
+            </a:pPr>
+            <a:r>
+              <a:rPr lang="en-US" sz="1100" dirty="0">
                 <a:solidFill>
                   <a:srgbClr val="5B6B79"/>
                 </a:solidFill>
@@ -10628,7 +12270,514 @@
                 <a:ea typeface="Calibri" pitchFamily="34" charset="-122"/>
                 <a:cs typeface="Calibri" pitchFamily="34" charset="-120"/>
               </a:rPr>
-              <a:t>App Groups, per-target file membership, and Info.plist entitlements all had to be wired by hand across two build targets (container app + keyboard extension) in Xcode.</a:t>
+              <a:t>0–15</a:t>
+            </a:r>
+            <a:endParaRPr lang="en-US" sz="1100" dirty="0"/>
+          </a:p>
+        </p:txBody>
+      </p:sp>
+      <p:sp>
+        <p:nvSpPr>
+          <p:cNvPr id="43" name="Shape 41"/>
+          <p:cNvSpPr/>
+          <p:nvPr/>
+        </p:nvSpPr>
+        <p:spPr>
+          <a:xfrm>
+            <a:off x="8321040" y="2990088"/>
+            <a:ext cx="256032" cy="146304"/>
+          </a:xfrm>
+          <a:prstGeom prst="roundRect">
+            <a:avLst>
+              <a:gd name="adj" fmla="val 18750"/>
+            </a:avLst>
+          </a:prstGeom>
+          <a:solidFill>
+            <a:srgbClr val="378ADD"/>
+          </a:solidFill>
+          <a:ln/>
+        </p:spPr>
+      </p:sp>
+      <p:sp>
+        <p:nvSpPr>
+          <p:cNvPr id="44" name="Text 42"/>
+          <p:cNvSpPr/>
+          <p:nvPr/>
+        </p:nvSpPr>
+        <p:spPr>
+          <a:xfrm>
+            <a:off x="8686800" y="2898648"/>
+            <a:ext cx="1280160" cy="274320"/>
+          </a:xfrm>
+          <a:prstGeom prst="rect">
+            <a:avLst/>
+          </a:prstGeom>
+          <a:noFill/>
+          <a:ln/>
+        </p:spPr>
+        <p:txBody>
+          <a:bodyPr wrap="square" lIns="0" tIns="0" rIns="0" bIns="0" rtlCol="0" anchor="ctr"/>
+          <a:lstStyle/>
+          <a:p>
+            <a:pPr indent="0" marL="0">
+              <a:buNone/>
+            </a:pPr>
+            <a:r>
+              <a:rPr lang="en-US" sz="1200" b="1" dirty="0">
+                <a:solidFill>
+                  <a:srgbClr val="0B2F42"/>
+                </a:solidFill>
+                <a:latin typeface="Calibri" pitchFamily="34" charset="0"/>
+                <a:ea typeface="Calibri" pitchFamily="34" charset="-122"/>
+                <a:cs typeface="Calibri" pitchFamily="34" charset="-120"/>
+              </a:rPr>
+              <a:t>Low</a:t>
+            </a:r>
+            <a:endParaRPr lang="en-US" sz="1200" dirty="0"/>
+          </a:p>
+        </p:txBody>
+      </p:sp>
+      <p:sp>
+        <p:nvSpPr>
+          <p:cNvPr id="45" name="Text 43"/>
+          <p:cNvSpPr/>
+          <p:nvPr/>
+        </p:nvSpPr>
+        <p:spPr>
+          <a:xfrm>
+            <a:off x="10378440" y="2898648"/>
+            <a:ext cx="731520" cy="274320"/>
+          </a:xfrm>
+          <a:prstGeom prst="rect">
+            <a:avLst/>
+          </a:prstGeom>
+          <a:noFill/>
+          <a:ln/>
+        </p:spPr>
+        <p:txBody>
+          <a:bodyPr wrap="square" lIns="0" tIns="0" rIns="0" bIns="0" rtlCol="0" anchor="ctr"/>
+          <a:lstStyle/>
+          <a:p>
+            <a:pPr algn="r" indent="0" marL="0">
+              <a:buNone/>
+            </a:pPr>
+            <a:r>
+              <a:rPr lang="en-US" sz="1100" dirty="0">
+                <a:solidFill>
+                  <a:srgbClr val="5B6B79"/>
+                </a:solidFill>
+                <a:latin typeface="Calibri" pitchFamily="34" charset="0"/>
+                <a:ea typeface="Calibri" pitchFamily="34" charset="-122"/>
+                <a:cs typeface="Calibri" pitchFamily="34" charset="-120"/>
+              </a:rPr>
+              <a:t>16–35</a:t>
+            </a:r>
+            <a:endParaRPr lang="en-US" sz="1100" dirty="0"/>
+          </a:p>
+        </p:txBody>
+      </p:sp>
+      <p:sp>
+        <p:nvSpPr>
+          <p:cNvPr id="46" name="Shape 44"/>
+          <p:cNvSpPr/>
+          <p:nvPr/>
+        </p:nvSpPr>
+        <p:spPr>
+          <a:xfrm>
+            <a:off x="8321040" y="3310128"/>
+            <a:ext cx="256032" cy="146304"/>
+          </a:xfrm>
+          <a:prstGeom prst="roundRect">
+            <a:avLst>
+              <a:gd name="adj" fmla="val 18750"/>
+            </a:avLst>
+          </a:prstGeom>
+          <a:solidFill>
+            <a:srgbClr val="BA7517"/>
+          </a:solidFill>
+          <a:ln/>
+        </p:spPr>
+      </p:sp>
+      <p:sp>
+        <p:nvSpPr>
+          <p:cNvPr id="47" name="Text 45"/>
+          <p:cNvSpPr/>
+          <p:nvPr/>
+        </p:nvSpPr>
+        <p:spPr>
+          <a:xfrm>
+            <a:off x="8686800" y="3218688"/>
+            <a:ext cx="1280160" cy="274320"/>
+          </a:xfrm>
+          <a:prstGeom prst="rect">
+            <a:avLst/>
+          </a:prstGeom>
+          <a:noFill/>
+          <a:ln/>
+        </p:spPr>
+        <p:txBody>
+          <a:bodyPr wrap="square" lIns="0" tIns="0" rIns="0" bIns="0" rtlCol="0" anchor="ctr"/>
+          <a:lstStyle/>
+          <a:p>
+            <a:pPr indent="0" marL="0">
+              <a:buNone/>
+            </a:pPr>
+            <a:r>
+              <a:rPr lang="en-US" sz="1200" b="1" dirty="0">
+                <a:solidFill>
+                  <a:srgbClr val="0B2F42"/>
+                </a:solidFill>
+                <a:latin typeface="Calibri" pitchFamily="34" charset="0"/>
+                <a:ea typeface="Calibri" pitchFamily="34" charset="-122"/>
+                <a:cs typeface="Calibri" pitchFamily="34" charset="-120"/>
+              </a:rPr>
+              <a:t>Moderate</a:t>
+            </a:r>
+            <a:endParaRPr lang="en-US" sz="1200" dirty="0"/>
+          </a:p>
+        </p:txBody>
+      </p:sp>
+      <p:sp>
+        <p:nvSpPr>
+          <p:cNvPr id="48" name="Text 46"/>
+          <p:cNvSpPr/>
+          <p:nvPr/>
+        </p:nvSpPr>
+        <p:spPr>
+          <a:xfrm>
+            <a:off x="10378440" y="3218688"/>
+            <a:ext cx="731520" cy="274320"/>
+          </a:xfrm>
+          <a:prstGeom prst="rect">
+            <a:avLst/>
+          </a:prstGeom>
+          <a:noFill/>
+          <a:ln/>
+        </p:spPr>
+        <p:txBody>
+          <a:bodyPr wrap="square" lIns="0" tIns="0" rIns="0" bIns="0" rtlCol="0" anchor="ctr"/>
+          <a:lstStyle/>
+          <a:p>
+            <a:pPr algn="r" indent="0" marL="0">
+              <a:buNone/>
+            </a:pPr>
+            <a:r>
+              <a:rPr lang="en-US" sz="1100" dirty="0">
+                <a:solidFill>
+                  <a:srgbClr val="5B6B79"/>
+                </a:solidFill>
+                <a:latin typeface="Calibri" pitchFamily="34" charset="0"/>
+                <a:ea typeface="Calibri" pitchFamily="34" charset="-122"/>
+                <a:cs typeface="Calibri" pitchFamily="34" charset="-120"/>
+              </a:rPr>
+              <a:t>36–60</a:t>
+            </a:r>
+            <a:endParaRPr lang="en-US" sz="1100" dirty="0"/>
+          </a:p>
+        </p:txBody>
+      </p:sp>
+      <p:sp>
+        <p:nvSpPr>
+          <p:cNvPr id="49" name="Shape 47"/>
+          <p:cNvSpPr/>
+          <p:nvPr/>
+        </p:nvSpPr>
+        <p:spPr>
+          <a:xfrm>
+            <a:off x="8321040" y="3630168"/>
+            <a:ext cx="256032" cy="146304"/>
+          </a:xfrm>
+          <a:prstGeom prst="roundRect">
+            <a:avLst>
+              <a:gd name="adj" fmla="val 18750"/>
+            </a:avLst>
+          </a:prstGeom>
+          <a:solidFill>
+            <a:srgbClr val="EF9F27"/>
+          </a:solidFill>
+          <a:ln/>
+        </p:spPr>
+      </p:sp>
+      <p:sp>
+        <p:nvSpPr>
+          <p:cNvPr id="50" name="Text 48"/>
+          <p:cNvSpPr/>
+          <p:nvPr/>
+        </p:nvSpPr>
+        <p:spPr>
+          <a:xfrm>
+            <a:off x="8686800" y="3538728"/>
+            <a:ext cx="1280160" cy="274320"/>
+          </a:xfrm>
+          <a:prstGeom prst="rect">
+            <a:avLst/>
+          </a:prstGeom>
+          <a:noFill/>
+          <a:ln/>
+        </p:spPr>
+        <p:txBody>
+          <a:bodyPr wrap="square" lIns="0" tIns="0" rIns="0" bIns="0" rtlCol="0" anchor="ctr"/>
+          <a:lstStyle/>
+          <a:p>
+            <a:pPr indent="0" marL="0">
+              <a:buNone/>
+            </a:pPr>
+            <a:r>
+              <a:rPr lang="en-US" sz="1200" b="1" dirty="0">
+                <a:solidFill>
+                  <a:srgbClr val="0B2F42"/>
+                </a:solidFill>
+                <a:latin typeface="Calibri" pitchFamily="34" charset="0"/>
+                <a:ea typeface="Calibri" pitchFamily="34" charset="-122"/>
+                <a:cs typeface="Calibri" pitchFamily="34" charset="-120"/>
+              </a:rPr>
+              <a:t>High</a:t>
+            </a:r>
+            <a:endParaRPr lang="en-US" sz="1200" dirty="0"/>
+          </a:p>
+        </p:txBody>
+      </p:sp>
+      <p:sp>
+        <p:nvSpPr>
+          <p:cNvPr id="51" name="Text 49"/>
+          <p:cNvSpPr/>
+          <p:nvPr/>
+        </p:nvSpPr>
+        <p:spPr>
+          <a:xfrm>
+            <a:off x="10378440" y="3538728"/>
+            <a:ext cx="731520" cy="274320"/>
+          </a:xfrm>
+          <a:prstGeom prst="rect">
+            <a:avLst/>
+          </a:prstGeom>
+          <a:noFill/>
+          <a:ln/>
+        </p:spPr>
+        <p:txBody>
+          <a:bodyPr wrap="square" lIns="0" tIns="0" rIns="0" bIns="0" rtlCol="0" anchor="ctr"/>
+          <a:lstStyle/>
+          <a:p>
+            <a:pPr algn="r" indent="0" marL="0">
+              <a:buNone/>
+            </a:pPr>
+            <a:r>
+              <a:rPr lang="en-US" sz="1100" dirty="0">
+                <a:solidFill>
+                  <a:srgbClr val="5B6B79"/>
+                </a:solidFill>
+                <a:latin typeface="Calibri" pitchFamily="34" charset="0"/>
+                <a:ea typeface="Calibri" pitchFamily="34" charset="-122"/>
+                <a:cs typeface="Calibri" pitchFamily="34" charset="-120"/>
+              </a:rPr>
+              <a:t>61–80</a:t>
+            </a:r>
+            <a:endParaRPr lang="en-US" sz="1100" dirty="0"/>
+          </a:p>
+        </p:txBody>
+      </p:sp>
+      <p:sp>
+        <p:nvSpPr>
+          <p:cNvPr id="52" name="Shape 50"/>
+          <p:cNvSpPr/>
+          <p:nvPr/>
+        </p:nvSpPr>
+        <p:spPr>
+          <a:xfrm>
+            <a:off x="8321040" y="3950208"/>
+            <a:ext cx="256032" cy="146304"/>
+          </a:xfrm>
+          <a:prstGeom prst="roundRect">
+            <a:avLst>
+              <a:gd name="adj" fmla="val 18750"/>
+            </a:avLst>
+          </a:prstGeom>
+          <a:solidFill>
+            <a:srgbClr val="E24B4A"/>
+          </a:solidFill>
+          <a:ln/>
+        </p:spPr>
+      </p:sp>
+      <p:sp>
+        <p:nvSpPr>
+          <p:cNvPr id="53" name="Text 51"/>
+          <p:cNvSpPr/>
+          <p:nvPr/>
+        </p:nvSpPr>
+        <p:spPr>
+          <a:xfrm>
+            <a:off x="8686800" y="3858768"/>
+            <a:ext cx="1280160" cy="274320"/>
+          </a:xfrm>
+          <a:prstGeom prst="rect">
+            <a:avLst/>
+          </a:prstGeom>
+          <a:noFill/>
+          <a:ln/>
+        </p:spPr>
+        <p:txBody>
+          <a:bodyPr wrap="square" lIns="0" tIns="0" rIns="0" bIns="0" rtlCol="0" anchor="ctr"/>
+          <a:lstStyle/>
+          <a:p>
+            <a:pPr indent="0" marL="0">
+              <a:buNone/>
+            </a:pPr>
+            <a:r>
+              <a:rPr lang="en-US" sz="1200" b="1" dirty="0">
+                <a:solidFill>
+                  <a:srgbClr val="0B2F42"/>
+                </a:solidFill>
+                <a:latin typeface="Calibri" pitchFamily="34" charset="0"/>
+                <a:ea typeface="Calibri" pitchFamily="34" charset="-122"/>
+                <a:cs typeface="Calibri" pitchFamily="34" charset="-120"/>
+              </a:rPr>
+              <a:t>Critical</a:t>
+            </a:r>
+            <a:endParaRPr lang="en-US" sz="1200" dirty="0"/>
+          </a:p>
+        </p:txBody>
+      </p:sp>
+      <p:sp>
+        <p:nvSpPr>
+          <p:cNvPr id="54" name="Text 52"/>
+          <p:cNvSpPr/>
+          <p:nvPr/>
+        </p:nvSpPr>
+        <p:spPr>
+          <a:xfrm>
+            <a:off x="10378440" y="3858768"/>
+            <a:ext cx="731520" cy="274320"/>
+          </a:xfrm>
+          <a:prstGeom prst="rect">
+            <a:avLst/>
+          </a:prstGeom>
+          <a:noFill/>
+          <a:ln/>
+        </p:spPr>
+        <p:txBody>
+          <a:bodyPr wrap="square" lIns="0" tIns="0" rIns="0" bIns="0" rtlCol="0" anchor="ctr"/>
+          <a:lstStyle/>
+          <a:p>
+            <a:pPr algn="r" indent="0" marL="0">
+              <a:buNone/>
+            </a:pPr>
+            <a:r>
+              <a:rPr lang="en-US" sz="1100" dirty="0">
+                <a:solidFill>
+                  <a:srgbClr val="5B6B79"/>
+                </a:solidFill>
+                <a:latin typeface="Calibri" pitchFamily="34" charset="0"/>
+                <a:ea typeface="Calibri" pitchFamily="34" charset="-122"/>
+                <a:cs typeface="Calibri" pitchFamily="34" charset="-120"/>
+              </a:rPr>
+              <a:t>81–100</a:t>
+            </a:r>
+            <a:endParaRPr lang="en-US" sz="1100" dirty="0"/>
+          </a:p>
+        </p:txBody>
+      </p:sp>
+      <p:sp>
+        <p:nvSpPr>
+          <p:cNvPr id="55" name="Text 53"/>
+          <p:cNvSpPr/>
+          <p:nvPr/>
+        </p:nvSpPr>
+        <p:spPr>
+          <a:xfrm>
+            <a:off x="731520" y="4645152"/>
+            <a:ext cx="7315200" cy="274320"/>
+          </a:xfrm>
+          <a:prstGeom prst="rect">
+            <a:avLst/>
+          </a:prstGeom>
+          <a:noFill/>
+          <a:ln/>
+        </p:spPr>
+        <p:txBody>
+          <a:bodyPr wrap="square" lIns="0" tIns="0" rIns="0" bIns="0" rtlCol="0" anchor="ctr"/>
+          <a:lstStyle/>
+          <a:p>
+            <a:pPr indent="0" marL="0">
+              <a:buNone/>
+            </a:pPr>
+            <a:r>
+              <a:rPr lang="en-US" sz="1150" b="1" spc="150" kern="0" dirty="0">
+                <a:solidFill>
+                  <a:srgbClr val="1C7293"/>
+                </a:solidFill>
+                <a:latin typeface="Calibri" pitchFamily="34" charset="0"/>
+                <a:ea typeface="Calibri" pitchFamily="34" charset="-122"/>
+                <a:cs typeface="Calibri" pitchFamily="34" charset="-120"/>
+              </a:rPr>
+              <a:t>VERIFIED AGAINST THE LIVE DATABASE</a:t>
+            </a:r>
+            <a:endParaRPr lang="en-US" sz="1150" dirty="0"/>
+          </a:p>
+        </p:txBody>
+      </p:sp>
+      <p:sp>
+        <p:nvSpPr>
+          <p:cNvPr id="56" name="Shape 54"/>
+          <p:cNvSpPr/>
+          <p:nvPr/>
+        </p:nvSpPr>
+        <p:spPr>
+          <a:xfrm>
+            <a:off x="731520" y="5010912"/>
+            <a:ext cx="5120640" cy="1234440"/>
+          </a:xfrm>
+          <a:prstGeom prst="roundRect">
+            <a:avLst>
+              <a:gd name="adj" fmla="val 5926"/>
+            </a:avLst>
+          </a:prstGeom>
+          <a:solidFill>
+            <a:srgbClr val="FFFFFF"/>
+          </a:solidFill>
+          <a:ln/>
+          <a:effectLst>
+            <a:outerShdw sx="100000" sy="100000" kx="0" ky="0" algn="bl" rotWithShape="0" blurRad="101600" dist="38100" dir="5400000">
+              <a:srgbClr val="000000">
+                <a:alpha val="12000"/>
+              </a:srgbClr>
+            </a:outerShdw>
+          </a:effectLst>
+        </p:spPr>
+      </p:sp>
+      <p:sp>
+        <p:nvSpPr>
+          <p:cNvPr id="57" name="Text 55"/>
+          <p:cNvSpPr/>
+          <p:nvPr/>
+        </p:nvSpPr>
+        <p:spPr>
+          <a:xfrm>
+            <a:off x="960120" y="5157216"/>
+            <a:ext cx="4663440" cy="274320"/>
+          </a:xfrm>
+          <a:prstGeom prst="rect">
+            <a:avLst/>
+          </a:prstGeom>
+          <a:noFill/>
+          <a:ln/>
+        </p:spPr>
+        <p:txBody>
+          <a:bodyPr wrap="square" lIns="0" tIns="0" rIns="0" bIns="0" rtlCol="0" anchor="ctr"/>
+          <a:lstStyle/>
+          <a:p>
+            <a:pPr indent="0" marL="0">
+              <a:buNone/>
+            </a:pPr>
+            <a:r>
+              <a:rPr lang="en-US" sz="1250" b="1" dirty="0">
+                <a:solidFill>
+                  <a:srgbClr val="0B2F42"/>
+                </a:solidFill>
+                <a:latin typeface="Calibri" pitchFamily="34" charset="0"/>
+                <a:ea typeface="Calibri" pitchFamily="34" charset="-122"/>
+                <a:cs typeface="Calibri" pitchFamily="34" charset="-120"/>
+              </a:rPr>
+              <a:t>“milk” — milk in your profile</a:t>
             </a:r>
             <a:endParaRPr lang="en-US" sz="1250" dirty="0"/>
           </a:p>
@@ -10636,113 +12785,30 @@
       </p:sp>
       <p:sp>
         <p:nvSpPr>
-          <p:cNvPr id="12" name="Shape 8"/>
-          <p:cNvSpPr/>
-          <p:nvPr/>
-        </p:nvSpPr>
-        <p:spPr>
-          <a:xfrm>
-            <a:off x="731520" y="5074920"/>
-            <a:ext cx="566928" cy="566928"/>
-          </a:xfrm>
-          <a:prstGeom prst="ellipse">
-            <a:avLst/>
-          </a:prstGeom>
-          <a:solidFill>
-            <a:srgbClr val="0B2F42"/>
-          </a:solidFill>
-          <a:ln/>
-        </p:spPr>
-      </p:sp>
-      <p:pic>
-        <p:nvPicPr>
-          <p:cNvPr id="13" name="Image 2" descr="icon-mobile.png">    </p:cNvPr>
-          <p:cNvPicPr>
-            <a:picLocks noChangeAspect="1"/>
-          </p:cNvPicPr>
-          <p:nvPr/>
-        </p:nvPicPr>
-        <p:blipFill>
-          <a:blip r:embed="rId3"/>
-          <a:stretch>
-            <a:fillRect/>
-          </a:stretch>
-        </p:blipFill>
-        <p:spPr>
-          <a:xfrm>
-            <a:off x="810890" y="5154290"/>
-            <a:ext cx="408188" cy="408188"/>
-          </a:xfrm>
-          <a:prstGeom prst="rect">
-            <a:avLst/>
-          </a:prstGeom>
-        </p:spPr>
-      </p:pic>
-      <p:sp>
-        <p:nvSpPr>
-          <p:cNvPr id="14" name="Text 9"/>
-          <p:cNvSpPr/>
-          <p:nvPr/>
-        </p:nvSpPr>
-        <p:spPr>
-          <a:xfrm>
-            <a:off x="1527048" y="5038344"/>
-            <a:ext cx="9811512" cy="320040"/>
-          </a:xfrm>
-          <a:prstGeom prst="rect">
-            <a:avLst/>
-          </a:prstGeom>
-          <a:noFill/>
-          <a:ln/>
-        </p:spPr>
-        <p:txBody>
-          <a:bodyPr wrap="square" lIns="0" tIns="0" rIns="0" bIns="0" rtlCol="0" anchor="ctr"/>
-          <a:lstStyle/>
-          <a:p>
-            <a:pPr indent="0" marL="0">
-              <a:buNone/>
-            </a:pPr>
-            <a:r>
-              <a:rPr lang="en-US" sz="1600" b="1" dirty="0">
-                <a:solidFill>
-                  <a:srgbClr val="1F2933"/>
-                </a:solidFill>
-                <a:latin typeface="Calibri" pitchFamily="34" charset="0"/>
-                <a:ea typeface="Calibri" pitchFamily="34" charset="-122"/>
-                <a:cs typeface="Calibri" pitchFamily="34" charset="-120"/>
-              </a:rPr>
-              <a:t>Real-device provisioning</a:t>
-            </a:r>
-            <a:endParaRPr lang="en-US" sz="1600" dirty="0"/>
-          </a:p>
-        </p:txBody>
-      </p:sp>
-      <p:sp>
-        <p:nvSpPr>
-          <p:cNvPr id="15" name="Text 10"/>
-          <p:cNvSpPr/>
-          <p:nvPr/>
-        </p:nvSpPr>
-        <p:spPr>
-          <a:xfrm>
-            <a:off x="1527048" y="5367528"/>
-            <a:ext cx="9811512" cy="685800"/>
-          </a:xfrm>
-          <a:prstGeom prst="rect">
-            <a:avLst/>
-          </a:prstGeom>
-          <a:noFill/>
-          <a:ln/>
-        </p:spPr>
-        <p:txBody>
-          <a:bodyPr wrap="square" lIns="0" tIns="0" rIns="0" bIns="0" rtlCol="0" anchor="t"/>
-          <a:lstStyle/>
-          <a:p>
-            <a:pPr indent="0" marL="0">
-              <a:buNone/>
-            </a:pPr>
-            <a:r>
-              <a:rPr lang="en-US" sz="1250" dirty="0">
+          <p:cNvPr id="58" name="Text 56"/>
+          <p:cNvSpPr/>
+          <p:nvPr/>
+        </p:nvSpPr>
+        <p:spPr>
+          <a:xfrm>
+            <a:off x="960120" y="5413248"/>
+            <a:ext cx="4663440" cy="274320"/>
+          </a:xfrm>
+          <a:prstGeom prst="rect">
+            <a:avLst/>
+          </a:prstGeom>
+          <a:noFill/>
+          <a:ln/>
+        </p:spPr>
+        <p:txBody>
+          <a:bodyPr wrap="square" lIns="0" tIns="0" rIns="0" bIns="0" rtlCol="0" anchor="ctr"/>
+          <a:lstStyle/>
+          <a:p>
+            <a:pPr indent="0" marL="0">
+              <a:buNone/>
+            </a:pPr>
+            <a:r>
+              <a:rPr lang="en-US" sz="1000" dirty="0">
                 <a:solidFill>
                   <a:srgbClr val="5B6B79"/>
                 </a:solidFill>
@@ -10750,7 +12816,158 @@
                 <a:ea typeface="Calibri" pitchFamily="34" charset="-122"/>
                 <a:cs typeface="Calibri" pitchFamily="34" charset="-120"/>
               </a:rPr>
-              <a:t>Scheme vs. destination mixups, trust dialogs, and first-run code-signing friction before the extension could run on a physical iPhone.</a:t>
+              <a:t>1 match: Milk/dairy (80) + 15 personal-allergen bonus</a:t>
+            </a:r>
+            <a:endParaRPr lang="en-US" sz="1000" dirty="0"/>
+          </a:p>
+        </p:txBody>
+      </p:sp>
+      <p:sp>
+        <p:nvSpPr>
+          <p:cNvPr id="59" name="Shape 57"/>
+          <p:cNvSpPr/>
+          <p:nvPr/>
+        </p:nvSpPr>
+        <p:spPr>
+          <a:xfrm>
+            <a:off x="960120" y="5797296"/>
+            <a:ext cx="4663440" cy="128016"/>
+          </a:xfrm>
+          <a:prstGeom prst="roundRect">
+            <a:avLst>
+              <a:gd name="adj" fmla="val 14286"/>
+            </a:avLst>
+          </a:prstGeom>
+          <a:solidFill>
+            <a:srgbClr val="EAF3F6"/>
+          </a:solidFill>
+          <a:ln/>
+        </p:spPr>
+      </p:sp>
+      <p:sp>
+        <p:nvSpPr>
+          <p:cNvPr id="60" name="Shape 58"/>
+          <p:cNvSpPr/>
+          <p:nvPr/>
+        </p:nvSpPr>
+        <p:spPr>
+          <a:xfrm>
+            <a:off x="960120" y="5797296"/>
+            <a:ext cx="4430268" cy="128016"/>
+          </a:xfrm>
+          <a:prstGeom prst="roundRect">
+            <a:avLst>
+              <a:gd name="adj" fmla="val 14286"/>
+            </a:avLst>
+          </a:prstGeom>
+          <a:solidFill>
+            <a:srgbClr val="E24B4A"/>
+          </a:solidFill>
+          <a:ln/>
+        </p:spPr>
+      </p:sp>
+      <p:sp>
+        <p:nvSpPr>
+          <p:cNvPr id="61" name="Text 59"/>
+          <p:cNvSpPr/>
+          <p:nvPr/>
+        </p:nvSpPr>
+        <p:spPr>
+          <a:xfrm>
+            <a:off x="960120" y="5971032"/>
+            <a:ext cx="4663440" cy="228600"/>
+          </a:xfrm>
+          <a:prstGeom prst="rect">
+            <a:avLst/>
+          </a:prstGeom>
+          <a:noFill/>
+          <a:ln/>
+        </p:spPr>
+        <p:txBody>
+          <a:bodyPr wrap="square" lIns="0" tIns="0" rIns="0" bIns="0" rtlCol="0" anchor="ctr"/>
+          <a:lstStyle/>
+          <a:p>
+            <a:pPr indent="0" marL="0">
+              <a:buNone/>
+            </a:pPr>
+            <a:r>
+              <a:rPr lang="en-US" sz="1150" b="1" dirty="0">
+                <a:solidFill>
+                  <a:srgbClr val="E24B4A"/>
+                </a:solidFill>
+                <a:latin typeface="Calibri" pitchFamily="34" charset="0"/>
+                <a:ea typeface="Calibri" pitchFamily="34" charset="-122"/>
+                <a:cs typeface="Calibri" pitchFamily="34" charset="-120"/>
+              </a:rPr>
+              <a:t>95/100 · Critical</a:t>
+            </a:r>
+            <a:endParaRPr lang="en-US" sz="1150" dirty="0"/>
+          </a:p>
+        </p:txBody>
+      </p:sp>
+      <p:sp>
+        <p:nvSpPr>
+          <p:cNvPr id="62" name="Shape 60"/>
+          <p:cNvSpPr/>
+          <p:nvPr/>
+        </p:nvSpPr>
+        <p:spPr>
+          <a:xfrm>
+            <a:off x="6217920" y="5010912"/>
+            <a:ext cx="5120640" cy="1234440"/>
+          </a:xfrm>
+          <a:prstGeom prst="roundRect">
+            <a:avLst>
+              <a:gd name="adj" fmla="val 5926"/>
+            </a:avLst>
+          </a:prstGeom>
+          <a:solidFill>
+            <a:srgbClr val="FFFFFF"/>
+          </a:solidFill>
+          <a:ln/>
+          <a:effectLst>
+            <a:outerShdw sx="100000" sy="100000" kx="0" ky="0" algn="bl" rotWithShape="0" blurRad="101600" dist="38100" dir="5400000">
+              <a:srgbClr val="000000">
+                <a:alpha val="12000"/>
+              </a:srgbClr>
+            </a:outerShdw>
+          </a:effectLst>
+        </p:spPr>
+      </p:sp>
+      <p:sp>
+        <p:nvSpPr>
+          <p:cNvPr id="63" name="Text 61"/>
+          <p:cNvSpPr/>
+          <p:nvPr/>
+        </p:nvSpPr>
+        <p:spPr>
+          <a:xfrm>
+            <a:off x="6446520" y="5157216"/>
+            <a:ext cx="4663440" cy="274320"/>
+          </a:xfrm>
+          <a:prstGeom prst="rect">
+            <a:avLst/>
+          </a:prstGeom>
+          <a:noFill/>
+          <a:ln/>
+        </p:spPr>
+        <p:txBody>
+          <a:bodyPr wrap="square" lIns="0" tIns="0" rIns="0" bIns="0" rtlCol="0" anchor="ctr"/>
+          <a:lstStyle/>
+          <a:p>
+            <a:pPr indent="0" marL="0">
+              <a:buNone/>
+            </a:pPr>
+            <a:r>
+              <a:rPr lang="en-US" sz="1250" b="1" dirty="0">
+                <a:solidFill>
+                  <a:srgbClr val="0B2F42"/>
+                </a:solidFill>
+                <a:latin typeface="Calibri" pitchFamily="34" charset="0"/>
+                <a:ea typeface="Calibri" pitchFamily="34" charset="-122"/>
+                <a:cs typeface="Calibri" pitchFamily="34" charset="-120"/>
+              </a:rPr>
+              <a:t>“quest bar”</a:t>
             </a:r>
             <a:endParaRPr lang="en-US" sz="1250" dirty="0"/>
           </a:p>
@@ -10758,7 +12975,129 @@
       </p:sp>
       <p:sp>
         <p:nvSpPr>
-          <p:cNvPr id="16" name="Text 11"/>
+          <p:cNvPr id="64" name="Text 62"/>
+          <p:cNvSpPr/>
+          <p:nvPr/>
+        </p:nvSpPr>
+        <p:spPr>
+          <a:xfrm>
+            <a:off x="6446520" y="5413248"/>
+            <a:ext cx="4663440" cy="274320"/>
+          </a:xfrm>
+          <a:prstGeom prst="rect">
+            <a:avLst/>
+          </a:prstGeom>
+          <a:noFill/>
+          <a:ln/>
+        </p:spPr>
+        <p:txBody>
+          <a:bodyPr wrap="square" lIns="0" tIns="0" rIns="0" bIns="0" rtlCol="0" anchor="ctr"/>
+          <a:lstStyle/>
+          <a:p>
+            <a:pPr indent="0" marL="0">
+              <a:buNone/>
+            </a:pPr>
+            <a:r>
+              <a:rPr lang="en-US" sz="1000" dirty="0">
+                <a:solidFill>
+                  <a:srgbClr val="5B6B79"/>
+                </a:solidFill>
+                <a:latin typeface="Calibri" pitchFamily="34" charset="0"/>
+                <a:ea typeface="Calibri" pitchFamily="34" charset="-122"/>
+                <a:cs typeface="Calibri" pitchFamily="34" charset="-120"/>
+              </a:rPr>
+              <a:t>5 matches, averaged: (80+80+60+60+40)/5</a:t>
+            </a:r>
+            <a:endParaRPr lang="en-US" sz="1000" dirty="0"/>
+          </a:p>
+        </p:txBody>
+      </p:sp>
+      <p:sp>
+        <p:nvSpPr>
+          <p:cNvPr id="65" name="Shape 63"/>
+          <p:cNvSpPr/>
+          <p:nvPr/>
+        </p:nvSpPr>
+        <p:spPr>
+          <a:xfrm>
+            <a:off x="6446520" y="5797296"/>
+            <a:ext cx="4663440" cy="128016"/>
+          </a:xfrm>
+          <a:prstGeom prst="roundRect">
+            <a:avLst>
+              <a:gd name="adj" fmla="val 14286"/>
+            </a:avLst>
+          </a:prstGeom>
+          <a:solidFill>
+            <a:srgbClr val="EAF3F6"/>
+          </a:solidFill>
+          <a:ln/>
+        </p:spPr>
+      </p:sp>
+      <p:sp>
+        <p:nvSpPr>
+          <p:cNvPr id="66" name="Shape 64"/>
+          <p:cNvSpPr/>
+          <p:nvPr/>
+        </p:nvSpPr>
+        <p:spPr>
+          <a:xfrm>
+            <a:off x="6446520" y="5797296"/>
+            <a:ext cx="2984602" cy="128016"/>
+          </a:xfrm>
+          <a:prstGeom prst="roundRect">
+            <a:avLst>
+              <a:gd name="adj" fmla="val 14286"/>
+            </a:avLst>
+          </a:prstGeom>
+          <a:solidFill>
+            <a:srgbClr val="EF9F27"/>
+          </a:solidFill>
+          <a:ln/>
+        </p:spPr>
+      </p:sp>
+      <p:sp>
+        <p:nvSpPr>
+          <p:cNvPr id="67" name="Text 65"/>
+          <p:cNvSpPr/>
+          <p:nvPr/>
+        </p:nvSpPr>
+        <p:spPr>
+          <a:xfrm>
+            <a:off x="6446520" y="5971032"/>
+            <a:ext cx="4663440" cy="228600"/>
+          </a:xfrm>
+          <a:prstGeom prst="rect">
+            <a:avLst/>
+          </a:prstGeom>
+          <a:noFill/>
+          <a:ln/>
+        </p:spPr>
+        <p:txBody>
+          <a:bodyPr wrap="square" lIns="0" tIns="0" rIns="0" bIns="0" rtlCol="0" anchor="ctr"/>
+          <a:lstStyle/>
+          <a:p>
+            <a:pPr indent="0" marL="0">
+              <a:buNone/>
+            </a:pPr>
+            <a:r>
+              <a:rPr lang="en-US" sz="1150" b="1" dirty="0">
+                <a:solidFill>
+                  <a:srgbClr val="EF9F27"/>
+                </a:solidFill>
+                <a:latin typeface="Calibri" pitchFamily="34" charset="0"/>
+                <a:ea typeface="Calibri" pitchFamily="34" charset="-122"/>
+                <a:cs typeface="Calibri" pitchFamily="34" charset="-120"/>
+              </a:rPr>
+              <a:t>64/100 · High</a:t>
+            </a:r>
+            <a:endParaRPr lang="en-US" sz="1150" dirty="0"/>
+          </a:p>
+        </p:txBody>
+      </p:sp>
+      <p:sp>
+        <p:nvSpPr>
+          <p:cNvPr id="68" name="Text 66"/>
           <p:cNvSpPr/>
           <p:nvPr/>
         </p:nvSpPr>

</xml_diff>

<commit_message>
Swap milk example for Vitamin Water Zero on the scoring slide
</commit_message>
<xml_diff>
--- a/docs/IngredientIQ-Demo.pptx
+++ b/docs/IngredientIQ-Demo.pptx
@@ -12777,7 +12777,7 @@
                 <a:ea typeface="Calibri" pitchFamily="34" charset="-122"/>
                 <a:cs typeface="Calibri" pitchFamily="34" charset="-120"/>
               </a:rPr>
-              <a:t>“milk” — milk in your profile</a:t>
+              <a:t>“vitamin water zero”</a:t>
             </a:r>
             <a:endParaRPr lang="en-US" sz="1250" dirty="0"/>
           </a:p>
@@ -12816,7 +12816,7 @@
                 <a:ea typeface="Calibri" pitchFamily="34" charset="-122"/>
                 <a:cs typeface="Calibri" pitchFamily="34" charset="-120"/>
               </a:rPr>
-              <a:t>1 match: Milk/dairy (80) + 15 personal-allergen bonus</a:t>
+              <a:t>2 matches, averaged: (60+60)/2</a:t>
             </a:r>
             <a:endParaRPr lang="en-US" sz="1000" dirty="0"/>
           </a:p>
@@ -12853,7 +12853,7 @@
         <p:spPr>
           <a:xfrm>
             <a:off x="960120" y="5797296"/>
-            <a:ext cx="4430268" cy="128016"/>
+            <a:ext cx="2798064" cy="128016"/>
           </a:xfrm>
           <a:prstGeom prst="roundRect">
             <a:avLst>
@@ -12861,7 +12861,7 @@
             </a:avLst>
           </a:prstGeom>
           <a:solidFill>
-            <a:srgbClr val="E24B4A"/>
+            <a:srgbClr val="BA7517"/>
           </a:solidFill>
           <a:ln/>
         </p:spPr>
@@ -12893,13 +12893,13 @@
             <a:r>
               <a:rPr lang="en-US" sz="1150" b="1" dirty="0">
                 <a:solidFill>
-                  <a:srgbClr val="E24B4A"/>
-                </a:solidFill>
-                <a:latin typeface="Calibri" pitchFamily="34" charset="0"/>
-                <a:ea typeface="Calibri" pitchFamily="34" charset="-122"/>
-                <a:cs typeface="Calibri" pitchFamily="34" charset="-120"/>
-              </a:rPr>
-              <a:t>95/100 · Critical</a:t>
+                  <a:srgbClr val="BA7517"/>
+                </a:solidFill>
+                <a:latin typeface="Calibri" pitchFamily="34" charset="0"/>
+                <a:ea typeface="Calibri" pitchFamily="34" charset="-122"/>
+                <a:cs typeface="Calibri" pitchFamily="34" charset="-120"/>
+              </a:rPr>
+              <a:t>60/100 · Moderate</a:t>
             </a:r>
             <a:endParaRPr lang="en-US" sz="1150" dirty="0"/>
           </a:p>

</xml_diff>